<commit_message>
Add Linear export and update deck for all three services
Download the 9 Project Apollo issues (with comments) from Linear into
dataExports/linear/, refresh the cross-service search screenshot and
update the deck's Linear card, search slide and next steps.

Co-Authored-By: Claude Opus 5.5 <noreply@anthropic.com>
</commit_message>
<xml_diff>
--- a/presentation/services-dashboard.pptx
+++ b/presentation/services-dashboard.pptx
@@ -2511,7 +2511,7 @@
                   <a:schemeClr val="tx1"/>
                 </a:solidFill>
               </a:rPr>
-              <a:t>Notion and GitHub done, Linear next</a:t>
+              <a:t>Notion, GitHub and Linear done</a:t>
             </a:r>
             <a:endParaRPr lang="en-US" sz="3000" dirty="0"/>
           </a:p>
@@ -2979,10 +2979,10 @@
             <a:r>
               <a:rPr lang="en-US" sz="4800" b="1" dirty="0">
                 <a:solidFill>
-                  <a:schemeClr val="accent2"/>
-                </a:solidFill>
-              </a:rPr>
-              <a:t>—</a:t>
+                  <a:schemeClr val="accent1"/>
+                </a:solidFill>
+              </a:rPr>
+              <a:t>9</a:t>
             </a:r>
             <a:endParaRPr lang="en-US" sz="4800" dirty="0"/>
           </a:p>
@@ -3018,7 +3018,7 @@
                   <a:schemeClr val="tx2"/>
                 </a:solidFill>
               </a:rPr>
-              <a:t>sign-in pending</a:t>
+              <a:t>Project Apollo issues with comments</a:t>
             </a:r>
             <a:endParaRPr lang="en-US" sz="1300" dirty="0"/>
           </a:p>
@@ -4943,7 +4943,7 @@
                   <a:schemeClr val="tx1"/>
                 </a:solidFill>
               </a:rPr>
-              <a:t>One search across Notion and GitHub</a:t>
+              <a:t>One search across Notion, GitHub and Linear</a:t>
             </a:r>
             <a:endParaRPr lang="en-US" sz="3000" dirty="0"/>
           </a:p>
@@ -5003,7 +5003,7 @@
                   <a:schemeClr val="accent1"/>
                 </a:solidFill>
               </a:rPr>
-              <a:t>28</a:t>
+              <a:t>37</a:t>
             </a:r>
             <a:endParaRPr lang="en-US" sz="1400" dirty="0"/>
           </a:p>
@@ -5017,7 +5017,7 @@
                   <a:schemeClr val="tx2"/>
                 </a:solidFill>
               </a:rPr>
-              <a:t>items from 2 services</a:t>
+              <a:t>items from 3 services</a:t>
             </a:r>
             <a:endParaRPr lang="en-US" sz="1400" dirty="0"/>
           </a:p>
@@ -5045,7 +5045,7 @@
                   <a:schemeClr val="accent2"/>
                 </a:solidFill>
               </a:rPr>
-              <a:t>15</a:t>
+              <a:t>21</a:t>
             </a:r>
             <a:endParaRPr lang="en-US" sz="1400" dirty="0"/>
           </a:p>
@@ -5697,7 +5697,7 @@
                   <a:schemeClr val="bg1"/>
                 </a:solidFill>
               </a:rPr>
-              <a:t>Next: Linear, then the final demo</a:t>
+              <a:t>Next: the final demo</a:t>
             </a:r>
             <a:endParaRPr lang="en-US" sz="4000" dirty="0"/>
           </a:p>
@@ -5735,7 +5735,7 @@
                   <a:schemeClr val="accent4"/>
                 </a:solidFill>
               </a:rPr>
-              <a:t>Sign in to Linear and download its issues  ·  Refresh screenshots with all three services  ·  Record the demo video</a:t>
+              <a:t>Record the demo video  ·  Final review of the deck</a:t>
             </a:r>
             <a:endParaRPr lang="en-US" sz="1800" dirty="0"/>
           </a:p>

</xml_diff>

<commit_message>
Polish presentation: alignment, wording, closing slide and notes
- Left-align titles to match the left-aligned body text
- Slide 3: clearer title, consistent service tags, muted Gmail card
- Slide 5: center the folder listing in its panel
- Slide 7: cleaner title; slide 6: typographic quotes
- Slide 8: replace the to-do list with a closing slide
- Update speaker notes for Linear and the three-service search
- Declare the .jpg content type so PowerPoint opens without repair

Co-Authored-By: Claude Opus 5.5 <noreply@anthropic.com>
</commit_message>
<xml_diff>
--- a/presentation/services-dashboard.pptx
+++ b/presentation/services-dashboard.pptx
@@ -718,7 +718,7 @@
           <a:p>
             <a:r>
               <a:rPr lang="en-US" dirty="0"/>
-              <a:t>Notion and GitHub are the required services and both are exported. Linear is my extra service; it replaced Google Calendar. Gmail was skipped with the professor's approval because Google's Gmail MCP server is only in a developer preview that does not accept test accounts. All data is fictional test data for the Project Apollo scenario.</a:t>
+              <a:t>Notion and GitHub are the required services; Linear is my extra service and replaced Google Calendar. All three are exported: 17 Notion pages, 11 GitHub repos, issues and PRs, and 9 Linear issues with comments. Gmail was skipped with the professor's approval because Google's Gmail MCP server is a developer preview that does not accept test accounts. All data is fictional test data for the Project Apollo scenario.</a:t>
             </a:r>
             <a:endParaRPr lang="en-US" dirty="0"/>
           </a:p>
@@ -982,7 +982,7 @@
           <a:p>
             <a:r>
               <a:rPr lang="en-US" dirty="0"/>
-              <a:t>Live demo: search Sarah Kim. Results come from Notion meeting notes and GitHub issues together, each labeled with its source. Filter chips narrow to one service, and each result links back to the original item.</a:t>
+              <a:t>Search Sarah Kim: 21 results from Notion meeting notes, GitHub issues and Linear issues together, each labeled with its source. Filter chips narrow to one service, the detail pane shows comments, and every result links back to the original item.</a:t>
             </a:r>
             <a:endParaRPr lang="en-US" dirty="0"/>
           </a:p>
@@ -1158,7 +1158,7 @@
           <a:p>
             <a:r>
               <a:rPr lang="en-US" dirty="0"/>
-              <a:t>Remaining work: authorize the Linear MCP server and run the download-linear skill, then update the screenshots and record the demo video.</a:t>
+              <a:t>Thank you. The code, the exported data and this deck are in the GitHub repository. Happy to take questions or show the dashboard live.</a:t>
             </a:r>
             <a:endParaRPr lang="en-US" dirty="0"/>
           </a:p>
@@ -1276,7 +1276,7 @@
         <p:txBody>
           <a:bodyPr wrap="square" rtlCol="0"/>
           <a:lstStyle>
-            <a:lvl1pPr indent="0" marL="0">
+            <a:lvl1pPr indent="0" marL="0" algn="l">
               <a:buNone/>
               <a:defRPr lang="en-US" sz="4000" b="1" dirty="0">
                 <a:solidFill>
@@ -1386,7 +1386,7 @@
         <p:txBody>
           <a:bodyPr wrap="square" rtlCol="0"/>
           <a:lstStyle>
-            <a:lvl1pPr indent="0" marL="0">
+            <a:lvl1pPr indent="0" marL="0" algn="l">
               <a:buNone/>
               <a:defRPr lang="en-US" sz="3000" b="1" dirty="0">
                 <a:solidFill>
@@ -2511,7 +2511,7 @@
                   <a:schemeClr val="tx1"/>
                 </a:solidFill>
               </a:rPr>
-              <a:t>Notion, GitHub and Linear done</a:t>
+              <a:t>Three services exported, one skipped</a:t>
             </a:r>
             <a:endParaRPr lang="en-US" sz="3000" dirty="0"/>
           </a:p>
@@ -2946,7 +2946,7 @@
                   <a:schemeClr val="accent3"/>
                 </a:solidFill>
               </a:rPr>
-              <a:t>Extra (replaced Google Calendar)</a:t>
+              <a:t>Extra service</a:t>
             </a:r>
             <a:endParaRPr lang="en-US" sz="1200" dirty="0"/>
           </a:p>
@@ -3018,7 +3018,7 @@
                   <a:schemeClr val="tx2"/>
                 </a:solidFill>
               </a:rPr>
-              <a:t>Project Apollo issues with comments</a:t>
+              <a:t>issues with comments; replaced Google Calendar</a:t>
             </a:r>
             <a:endParaRPr lang="en-US" sz="1300" dirty="0"/>
           </a:p>
@@ -3187,7 +3187,7 @@
                   <a:schemeClr val="tx2"/>
                 </a:solidFill>
               </a:rPr>
-              <a:t>professor approved: MCP preview rejects test accounts</a:t>
+              <a:t>skipped with the professor’s approval</a:t>
             </a:r>
             <a:endParaRPr lang="en-US" sz="1300" dirty="0"/>
           </a:p>
@@ -4012,10 +4012,16 @@
           <a:ln/>
         </p:spPr>
         <p:txBody>
-          <a:bodyPr wrap="square" lIns="0" tIns="0" rIns="0" bIns="0" rtlCol="0" anchor="t"/>
-          <a:lstStyle/>
-          <a:p>
-            <a:pPr indent="0" marL="0">
+          <a:bodyPr wrap="square" lIns="0" tIns="0" rIns="0" bIns="0" rtlCol="0" anchor="ctr"/>
+          <a:lstStyle/>
+          <a:p>
+            <a:pPr indent="0" marL="0">
+              <a:lnSpc>
+                <a:spcPct val="135000"/>
+              </a:lnSpc>
+              <a:spcAft>
+                <a:spcPts val="0"/>
+              </a:spcAft>
               <a:buNone/>
             </a:pPr>
             <a:r>
@@ -4033,6 +4039,12 @@
           </a:p>
           <a:p>
             <a:pPr indent="0" marL="0">
+              <a:lnSpc>
+                <a:spcPct val="135000"/>
+              </a:lnSpc>
+              <a:spcAft>
+                <a:spcPts val="0"/>
+              </a:spcAft>
               <a:buNone/>
             </a:pPr>
             <a:r>
@@ -4050,6 +4062,12 @@
           </a:p>
           <a:p>
             <a:pPr indent="0" marL="0">
+              <a:lnSpc>
+                <a:spcPct val="135000"/>
+              </a:lnSpc>
+              <a:spcAft>
+                <a:spcPts val="0"/>
+              </a:spcAft>
               <a:buNone/>
             </a:pPr>
             <a:r>
@@ -4067,6 +4085,12 @@
           </a:p>
           <a:p>
             <a:pPr indent="0" marL="0">
+              <a:lnSpc>
+                <a:spcPct val="135000"/>
+              </a:lnSpc>
+              <a:spcAft>
+                <a:spcPts val="0"/>
+              </a:spcAft>
               <a:buNone/>
             </a:pPr>
             <a:r>
@@ -4084,6 +4108,12 @@
           </a:p>
           <a:p>
             <a:pPr indent="0" marL="0">
+              <a:lnSpc>
+                <a:spcPct val="135000"/>
+              </a:lnSpc>
+              <a:spcAft>
+                <a:spcPts val="0"/>
+              </a:spcAft>
               <a:buNone/>
             </a:pPr>
             <a:r>
@@ -4101,6 +4131,12 @@
           </a:p>
           <a:p>
             <a:pPr indent="0" marL="0">
+              <a:lnSpc>
+                <a:spcPct val="135000"/>
+              </a:lnSpc>
+              <a:spcAft>
+                <a:spcPts val="0"/>
+              </a:spcAft>
               <a:buNone/>
             </a:pPr>
             <a:r>
@@ -4118,6 +4154,12 @@
           </a:p>
           <a:p>
             <a:pPr indent="0" marL="0">
+              <a:lnSpc>
+                <a:spcPct val="135000"/>
+              </a:lnSpc>
+              <a:spcAft>
+                <a:spcPts val="0"/>
+              </a:spcAft>
               <a:buNone/>
             </a:pPr>
             <a:r>
@@ -4135,6 +4177,12 @@
           </a:p>
           <a:p>
             <a:pPr indent="0" marL="0">
+              <a:lnSpc>
+                <a:spcPct val="135000"/>
+              </a:lnSpc>
+              <a:spcAft>
+                <a:spcPts val="0"/>
+              </a:spcAft>
               <a:buNone/>
             </a:pPr>
             <a:r>
@@ -4152,6 +4200,12 @@
           </a:p>
           <a:p>
             <a:pPr indent="0" marL="0">
+              <a:lnSpc>
+                <a:spcPct val="135000"/>
+              </a:lnSpc>
+              <a:spcAft>
+                <a:spcPts val="0"/>
+              </a:spcAft>
               <a:buNone/>
             </a:pPr>
             <a:r>
@@ -4169,6 +4223,12 @@
           </a:p>
           <a:p>
             <a:pPr indent="0" marL="0">
+              <a:lnSpc>
+                <a:spcPct val="135000"/>
+              </a:lnSpc>
+              <a:spcAft>
+                <a:spcPts val="0"/>
+              </a:spcAft>
               <a:buNone/>
             </a:pPr>
             <a:r>
@@ -5059,7 +5119,7 @@
                   <a:schemeClr val="tx2"/>
                 </a:solidFill>
               </a:rPr>
-              <a:t>results for "Sarah Kim", each tagged with its service</a:t>
+              <a:t>results for “Sarah Kim”, each tagged with its service</a:t>
             </a:r>
             <a:endParaRPr lang="en-US" sz="1400" dirty="0"/>
           </a:p>
@@ -5167,7 +5227,7 @@
                   <a:schemeClr val="tx1"/>
                 </a:solidFill>
               </a:rPr>
-              <a:t>No secrets, and easy to extend</a:t>
+              <a:t>Secure by default, easy to extend</a:t>
             </a:r>
             <a:endParaRPr lang="en-US" sz="3000" dirty="0"/>
           </a:p>
@@ -5697,7 +5757,7 @@
                   <a:schemeClr val="bg1"/>
                 </a:solidFill>
               </a:rPr>
-              <a:t>Next: the final demo</a:t>
+              <a:t>Thank you</a:t>
             </a:r>
             <a:endParaRPr lang="en-US" sz="4000" dirty="0"/>
           </a:p>
@@ -5735,7 +5795,21 @@
                   <a:schemeClr val="accent4"/>
                 </a:solidFill>
               </a:rPr>
-              <a:t>Record the demo video  ·  Final review of the deck</a:t>
+              <a:t>Questions?</a:t>
+            </a:r>
+            <a:endParaRPr lang="en-US" sz="1800" dirty="0"/>
+          </a:p>
+          <a:p>
+            <a:pPr indent="0" marL="0">
+              <a:buNone/>
+            </a:pPr>
+            <a:r>
+              <a:rPr lang="en-US" sz="1800" dirty="0">
+                <a:solidFill>
+                  <a:schemeClr val="accent4"/>
+                </a:solidFill>
+              </a:rPr>
+              <a:t>github.com/nyohayon-jpg/hw-services-dashboard</a:t>
             </a:r>
             <a:endParaRPr lang="en-US" sz="1800" dirty="0"/>
           </a:p>

</xml_diff>

<commit_message>
Remove Gmail card from the services slide
Slide 3 now shows the three exported services on the same 3-card grid
as slide 2. The Gmail reason stays in the speaker notes in case it is asked.

Co-Authored-By: Claude Opus 5.5 <noreply@anthropic.com>
</commit_message>
<xml_diff>
--- a/presentation/services-dashboard.pptx
+++ b/presentation/services-dashboard.pptx
@@ -718,7 +718,7 @@
           <a:p>
             <a:r>
               <a:rPr lang="en-US" dirty="0"/>
-              <a:t>Notion and GitHub are the required services; Linear is my extra service and replaced Google Calendar. All three are exported: 17 Notion pages, 11 GitHub repos, issues and PRs, and 9 Linear issues with comments. Gmail was skipped with the professor's approval because Google's Gmail MCP server is a developer preview that does not accept test accounts. All data is fictional test data for the Project Apollo scenario.</a:t>
+              <a:t>Notion and GitHub are the required services; Linear is my extra service and replaced Google Calendar. All three are exported: 17 Notion pages, 11 GitHub repos, issues and PRs, and 9 Linear issues with comments. All data is fictional test data for the Project Apollo scenario. If asked: Gmail was skipped with the professor's approval because Google's Gmail MCP server is a developer preview that does not accept test accounts.</a:t>
             </a:r>
             <a:endParaRPr lang="en-US" dirty="0"/>
           </a:p>
@@ -2511,7 +2511,7 @@
                   <a:schemeClr val="tx1"/>
                 </a:solidFill>
               </a:rPr>
-              <a:t>Three services exported, one skipped</a:t>
+              <a:t>Three services, one search</a:t>
             </a:r>
             <a:endParaRPr lang="en-US" sz="3000" dirty="0"/>
           </a:p>
@@ -2526,7 +2526,7 @@
         <p:spPr>
           <a:xfrm>
             <a:off x="457200" y="1280160"/>
-            <a:ext cx="1920240" cy="3200400"/>
+            <a:ext cx="2560320" cy="3200400"/>
           </a:xfrm>
           <a:prstGeom prst="roundRect">
             <a:avLst>
@@ -2548,7 +2548,7 @@
         <p:spPr>
           <a:xfrm>
             <a:off x="640080" y="1463040"/>
-            <a:ext cx="1554480" cy="411480"/>
+            <a:ext cx="2194560" cy="411480"/>
           </a:xfrm>
           <a:prstGeom prst="rect">
             <a:avLst/>
@@ -2587,7 +2587,7 @@
         <p:spPr>
           <a:xfrm>
             <a:off x="640080" y="1874520"/>
-            <a:ext cx="1554480" cy="548640"/>
+            <a:ext cx="2194560" cy="548640"/>
           </a:xfrm>
           <a:prstGeom prst="rect">
             <a:avLst/>
@@ -2623,7 +2623,7 @@
         <p:spPr>
           <a:xfrm>
             <a:off x="640080" y="2514600"/>
-            <a:ext cx="1554480" cy="822960"/>
+            <a:ext cx="2194560" cy="822960"/>
           </a:xfrm>
           <a:prstGeom prst="rect">
             <a:avLst/>
@@ -2659,7 +2659,7 @@
         <p:spPr>
           <a:xfrm>
             <a:off x="640080" y="3383280"/>
-            <a:ext cx="1554480" cy="914400"/>
+            <a:ext cx="2194560" cy="914400"/>
           </a:xfrm>
           <a:prstGeom prst="rect">
             <a:avLst/>
@@ -2694,8 +2694,8 @@
         </p:nvSpPr>
         <p:spPr>
           <a:xfrm>
-            <a:off x="2560320" y="1280160"/>
-            <a:ext cx="1920240" cy="3200400"/>
+            <a:off x="3291840" y="1280160"/>
+            <a:ext cx="2560320" cy="3200400"/>
           </a:xfrm>
           <a:prstGeom prst="roundRect">
             <a:avLst>
@@ -2716,8 +2716,8 @@
         </p:nvSpPr>
         <p:spPr>
           <a:xfrm>
-            <a:off x="2743200" y="1463040"/>
-            <a:ext cx="1554480" cy="411480"/>
+            <a:off x="3474720" y="1463040"/>
+            <a:ext cx="2194560" cy="411480"/>
           </a:xfrm>
           <a:prstGeom prst="rect">
             <a:avLst/>
@@ -2755,8 +2755,8 @@
         </p:nvSpPr>
         <p:spPr>
           <a:xfrm>
-            <a:off x="2743200" y="1874520"/>
-            <a:ext cx="1554480" cy="548640"/>
+            <a:off x="3474720" y="1874520"/>
+            <a:ext cx="2194560" cy="548640"/>
           </a:xfrm>
           <a:prstGeom prst="rect">
             <a:avLst/>
@@ -2791,8 +2791,8 @@
         </p:nvSpPr>
         <p:spPr>
           <a:xfrm>
-            <a:off x="2743200" y="2514600"/>
-            <a:ext cx="1554480" cy="822960"/>
+            <a:off x="3474720" y="2514600"/>
+            <a:ext cx="2194560" cy="822960"/>
           </a:xfrm>
           <a:prstGeom prst="rect">
             <a:avLst/>
@@ -2827,8 +2827,8 @@
         </p:nvSpPr>
         <p:spPr>
           <a:xfrm>
-            <a:off x="2743200" y="3383280"/>
-            <a:ext cx="1554480" cy="914400"/>
+            <a:off x="3474720" y="3383280"/>
+            <a:ext cx="2194560" cy="914400"/>
           </a:xfrm>
           <a:prstGeom prst="rect">
             <a:avLst/>
@@ -2863,8 +2863,8 @@
         </p:nvSpPr>
         <p:spPr>
           <a:xfrm>
-            <a:off x="4663440" y="1280160"/>
-            <a:ext cx="1920240" cy="3200400"/>
+            <a:off x="6126480" y="1280160"/>
+            <a:ext cx="2560320" cy="3200400"/>
           </a:xfrm>
           <a:prstGeom prst="roundRect">
             <a:avLst>
@@ -2885,8 +2885,8 @@
         </p:nvSpPr>
         <p:spPr>
           <a:xfrm>
-            <a:off x="4846320" y="1463040"/>
-            <a:ext cx="1554480" cy="411480"/>
+            <a:off x="6309360" y="1463040"/>
+            <a:ext cx="2194560" cy="411480"/>
           </a:xfrm>
           <a:prstGeom prst="rect">
             <a:avLst/>
@@ -2924,8 +2924,8 @@
         </p:nvSpPr>
         <p:spPr>
           <a:xfrm>
-            <a:off x="4846320" y="1874520"/>
-            <a:ext cx="1554480" cy="548640"/>
+            <a:off x="6309360" y="1874520"/>
+            <a:ext cx="2194560" cy="548640"/>
           </a:xfrm>
           <a:prstGeom prst="rect">
             <a:avLst/>
@@ -2960,8 +2960,8 @@
         </p:nvSpPr>
         <p:spPr>
           <a:xfrm>
-            <a:off x="4846320" y="2514600"/>
-            <a:ext cx="1554480" cy="822960"/>
+            <a:off x="6309360" y="2514600"/>
+            <a:ext cx="2194560" cy="822960"/>
           </a:xfrm>
           <a:prstGeom prst="rect">
             <a:avLst/>
@@ -2996,8 +2996,8 @@
         </p:nvSpPr>
         <p:spPr>
           <a:xfrm>
-            <a:off x="4846320" y="3383280"/>
-            <a:ext cx="1554480" cy="914400"/>
+            <a:off x="6309360" y="3383280"/>
+            <a:ext cx="2194560" cy="914400"/>
           </a:xfrm>
           <a:prstGeom prst="rect">
             <a:avLst/>
@@ -3019,175 +3019,6 @@
                 </a:solidFill>
               </a:rPr>
               <a:t>issues with comments; replaced Google Calendar</a:t>
-            </a:r>
-            <a:endParaRPr lang="en-US" sz="1300" dirty="0"/>
-          </a:p>
-        </p:txBody>
-      </p:sp>
-      <p:sp>
-        <p:nvSpPr>
-          <p:cNvPr id="18" name="Shape 16"/>
-          <p:cNvSpPr/>
-          <p:nvPr/>
-        </p:nvSpPr>
-        <p:spPr>
-          <a:xfrm>
-            <a:off x="6766560" y="1280160"/>
-            <a:ext cx="1920240" cy="3200400"/>
-          </a:xfrm>
-          <a:prstGeom prst="roundRect">
-            <a:avLst>
-              <a:gd name="adj" fmla="val 5714"/>
-            </a:avLst>
-          </a:prstGeom>
-          <a:solidFill>
-            <a:schemeClr val="bg2"/>
-          </a:solidFill>
-          <a:ln/>
-        </p:spPr>
-      </p:sp>
-      <p:sp>
-        <p:nvSpPr>
-          <p:cNvPr id="19" name="Text 17"/>
-          <p:cNvSpPr txBox="1"/>
-          <p:nvPr/>
-        </p:nvSpPr>
-        <p:spPr>
-          <a:xfrm>
-            <a:off x="6949440" y="1463040"/>
-            <a:ext cx="1554480" cy="411480"/>
-          </a:xfrm>
-          <a:prstGeom prst="rect">
-            <a:avLst/>
-          </a:prstGeom>
-          <a:noFill/>
-          <a:ln/>
-        </p:spPr>
-        <p:txBody>
-          <a:bodyPr wrap="square" lIns="0" tIns="0" rIns="0" bIns="0" rtlCol="0" anchor="ctr"/>
-          <a:lstStyle/>
-          <a:p>
-            <a:pPr indent="0" marL="0">
-              <a:buNone/>
-            </a:pPr>
-            <a:r>
-              <a:rPr lang="en-US" sz="2000" b="1" dirty="0">
-                <a:solidFill>
-                  <a:schemeClr val="tx1"/>
-                </a:solidFill>
-                <a:latin typeface="Cambria" pitchFamily="34" charset="0"/>
-                <a:ea typeface="Cambria" pitchFamily="34" charset="-122"/>
-                <a:cs typeface="Cambria" pitchFamily="34" charset="-120"/>
-              </a:rPr>
-              <a:t>Gmail</a:t>
-            </a:r>
-            <a:endParaRPr lang="en-US" sz="2000" dirty="0"/>
-          </a:p>
-        </p:txBody>
-      </p:sp>
-      <p:sp>
-        <p:nvSpPr>
-          <p:cNvPr id="20" name="Text 18"/>
-          <p:cNvSpPr txBox="1"/>
-          <p:nvPr/>
-        </p:nvSpPr>
-        <p:spPr>
-          <a:xfrm>
-            <a:off x="6949440" y="1874520"/>
-            <a:ext cx="1554480" cy="548640"/>
-          </a:xfrm>
-          <a:prstGeom prst="rect">
-            <a:avLst/>
-          </a:prstGeom>
-          <a:noFill/>
-          <a:ln/>
-        </p:spPr>
-        <p:txBody>
-          <a:bodyPr wrap="square" lIns="0" tIns="0" rIns="0" bIns="0" rtlCol="0" anchor="t"/>
-          <a:lstStyle/>
-          <a:p>
-            <a:pPr indent="0" marL="0">
-              <a:buNone/>
-            </a:pPr>
-            <a:r>
-              <a:rPr lang="en-US" sz="1200" dirty="0">
-                <a:solidFill>
-                  <a:schemeClr val="accent3"/>
-                </a:solidFill>
-              </a:rPr>
-              <a:t>Skipped</a:t>
-            </a:r>
-            <a:endParaRPr lang="en-US" sz="1200" dirty="0"/>
-          </a:p>
-        </p:txBody>
-      </p:sp>
-      <p:sp>
-        <p:nvSpPr>
-          <p:cNvPr id="21" name="Text 19"/>
-          <p:cNvSpPr txBox="1"/>
-          <p:nvPr/>
-        </p:nvSpPr>
-        <p:spPr>
-          <a:xfrm>
-            <a:off x="6949440" y="2514600"/>
-            <a:ext cx="1554480" cy="822960"/>
-          </a:xfrm>
-          <a:prstGeom prst="rect">
-            <a:avLst/>
-          </a:prstGeom>
-          <a:noFill/>
-          <a:ln/>
-        </p:spPr>
-        <p:txBody>
-          <a:bodyPr wrap="square" lIns="0" tIns="0" rIns="0" bIns="0" rtlCol="0" anchor="ctr"/>
-          <a:lstStyle/>
-          <a:p>
-            <a:pPr indent="0" marL="0">
-              <a:buNone/>
-            </a:pPr>
-            <a:r>
-              <a:rPr lang="en-US" sz="4800" b="1" dirty="0">
-                <a:solidFill>
-                  <a:schemeClr val="accent3"/>
-                </a:solidFill>
-              </a:rPr>
-              <a:t>—</a:t>
-            </a:r>
-            <a:endParaRPr lang="en-US" sz="4800" dirty="0"/>
-          </a:p>
-        </p:txBody>
-      </p:sp>
-      <p:sp>
-        <p:nvSpPr>
-          <p:cNvPr id="22" name="Text 20"/>
-          <p:cNvSpPr txBox="1"/>
-          <p:nvPr/>
-        </p:nvSpPr>
-        <p:spPr>
-          <a:xfrm>
-            <a:off x="6949440" y="3383280"/>
-            <a:ext cx="1554480" cy="914400"/>
-          </a:xfrm>
-          <a:prstGeom prst="rect">
-            <a:avLst/>
-          </a:prstGeom>
-          <a:noFill/>
-          <a:ln/>
-        </p:spPr>
-        <p:txBody>
-          <a:bodyPr wrap="square" lIns="0" tIns="0" rIns="0" bIns="0" rtlCol="0" anchor="t"/>
-          <a:lstStyle/>
-          <a:p>
-            <a:pPr indent="0" marL="0">
-              <a:buNone/>
-            </a:pPr>
-            <a:r>
-              <a:rPr lang="en-US" sz="1300" dirty="0">
-                <a:solidFill>
-                  <a:schemeClr val="tx2"/>
-                </a:solidFill>
-              </a:rPr>
-              <a:t>skipped with the professor’s approval</a:t>
             </a:r>
             <a:endParaRPr lang="en-US" sz="1300" dirty="0"/>
           </a:p>

</xml_diff>

<commit_message>
Add original-vs-dashboard slides and the demo video script
- One slide per service (Notion, GitHub, Linear) showing the original
  test content next to the same item in the dashboard, as the assignment
  requires, with the six screenshots in presentation/screenshots/
- presentation/video-script.md: a script under 3 minutes that logs into
  Linear, downloads through Claude Code, starts the dashboard and searches

Co-Authored-By: Claude Opus 5.5 <noreply@anthropic.com>
</commit_message>
<xml_diff>
--- a/presentation/services-dashboard.pptx
+++ b/presentation/services-dashboard.pptx
@@ -11,6 +11,9 @@
     <p:sldId id="259" r:id="rId5"/>
     <p:sldId id="260" r:id="rId6"/>
     <p:sldId id="261" r:id="rId7"/>
+    <p:sldId id="264" r:id="rId15"/>
+    <p:sldId id="265" r:id="rId16"/>
+    <p:sldId id="266" r:id="rId17"/>
     <p:sldId id="262" r:id="rId8"/>
     <p:sldId id="263" r:id="rId9"/>
   </p:sldIdLst>
@@ -584,6 +587,146 @@
 </p:notes>
 </file>
 
+<file path=ppt/notesSlides/notesSlide10.xml><?xml version="1.0" encoding="utf-8"?>
+<p:notes xmlns:a="http://schemas.openxmlformats.org/drawingml/2006/main" xmlns:p="http://schemas.openxmlformats.org/presentationml/2006/main" xmlns:r="http://schemas.openxmlformats.org/officeDocument/2006/relationships">
+  <p:cSld>
+    <p:spTree>
+      <p:nvGrpSpPr>
+        <p:cNvPr id="1" name=""/>
+        <p:cNvGrpSpPr/>
+        <p:nvPr/>
+      </p:nvGrpSpPr>
+      <p:grpSpPr>
+        <a:xfrm>
+          <a:off x="0" y="0"/>
+          <a:ext cx="0" cy="0"/>
+          <a:chOff x="0" y="0"/>
+          <a:chExt cx="0" cy="0"/>
+        </a:xfrm>
+      </p:grpSpPr>
+      <p:sp>
+        <p:nvSpPr>
+          <p:cNvPr id="2" name="Slide Image Placeholder 1"/>
+          <p:cNvSpPr>
+            <a:spLocks noGrp="1"/>
+          </p:cNvSpPr>
+          <p:nvPr>
+            <p:ph type="sldImg" idx="2"/>
+          </p:nvPr>
+        </p:nvSpPr>
+        <p:spPr/>
+      </p:sp>
+      <p:sp>
+        <p:nvSpPr>
+          <p:cNvPr id="3" name="Notes Placeholder 2"/>
+          <p:cNvSpPr>
+            <a:spLocks noGrp="1"/>
+          </p:cNvSpPr>
+          <p:nvPr>
+            <p:ph type="body" idx="3" sz="quarter"/>
+          </p:nvPr>
+        </p:nvSpPr>
+        <p:spPr/>
+        <p:txBody>
+          <a:bodyPr/>
+          <a:lstStyle/>
+          <a:p>
+            <a:r>
+              <a:t>Left: the original GitHub issue in the public test repo. Right: the same issue in the dashboard, with its labels, state, author and comment, tagged GITHUB.</a:t>
+            </a:r>
+          </a:p>
+        </p:txBody>
+      </p:sp>
+      <p:sp>
+        <p:nvSpPr>
+          <p:cNvPr id="4" name="Slide Number Placeholder 3"/>
+          <p:cNvSpPr>
+            <a:spLocks noGrp="1"/>
+          </p:cNvSpPr>
+          <p:nvPr>
+            <p:ph type="sldNum" idx="5" sz="quarter"/>
+          </p:nvPr>
+        </p:nvSpPr>
+        <p:spPr/>
+      </p:sp>
+    </p:spTree>
+  </p:cSld>
+  <p:clrMapOvr>
+    <a:masterClrMapping/>
+  </p:clrMapOvr>
+</p:notes>
+</file>
+
+<file path=ppt/notesSlides/notesSlide11.xml><?xml version="1.0" encoding="utf-8"?>
+<p:notes xmlns:a="http://schemas.openxmlformats.org/drawingml/2006/main" xmlns:p="http://schemas.openxmlformats.org/presentationml/2006/main" xmlns:r="http://schemas.openxmlformats.org/officeDocument/2006/relationships">
+  <p:cSld>
+    <p:spTree>
+      <p:nvGrpSpPr>
+        <p:cNvPr id="1" name=""/>
+        <p:cNvGrpSpPr/>
+        <p:nvPr/>
+      </p:nvGrpSpPr>
+      <p:grpSpPr>
+        <a:xfrm>
+          <a:off x="0" y="0"/>
+          <a:ext cx="0" cy="0"/>
+          <a:chOff x="0" y="0"/>
+          <a:chExt cx="0" cy="0"/>
+        </a:xfrm>
+      </p:grpSpPr>
+      <p:sp>
+        <p:nvSpPr>
+          <p:cNvPr id="2" name="Slide Image Placeholder 1"/>
+          <p:cNvSpPr>
+            <a:spLocks noGrp="1"/>
+          </p:cNvSpPr>
+          <p:nvPr>
+            <p:ph type="sldImg" idx="2"/>
+          </p:nvPr>
+        </p:nvSpPr>
+        <p:spPr/>
+      </p:sp>
+      <p:sp>
+        <p:nvSpPr>
+          <p:cNvPr id="3" name="Notes Placeholder 2"/>
+          <p:cNvSpPr>
+            <a:spLocks noGrp="1"/>
+          </p:cNvSpPr>
+          <p:nvPr>
+            <p:ph type="body" idx="3" sz="quarter"/>
+          </p:nvPr>
+        </p:nvSpPr>
+        <p:spPr/>
+        <p:txBody>
+          <a:bodyPr/>
+          <a:lstStyle/>
+          <a:p>
+            <a:r>
+              <a:t>Left: the original Linear issue in the test workspace. Right: the same issue in the dashboard, with its status, priority and comment, tagged LINEAR.</a:t>
+            </a:r>
+          </a:p>
+        </p:txBody>
+      </p:sp>
+      <p:sp>
+        <p:nvSpPr>
+          <p:cNvPr id="4" name="Slide Number Placeholder 3"/>
+          <p:cNvSpPr>
+            <a:spLocks noGrp="1"/>
+          </p:cNvSpPr>
+          <p:nvPr>
+            <p:ph type="sldNum" idx="5" sz="quarter"/>
+          </p:nvPr>
+        </p:nvSpPr>
+        <p:spPr/>
+      </p:sp>
+    </p:spTree>
+  </p:cSld>
+  <p:clrMapOvr>
+    <a:masterClrMapping/>
+  </p:clrMapOvr>
+</p:notes>
+</file>
+
 <file path=ppt/notesSlides/notesSlide2.xml><?xml version="1.0" encoding="utf-8"?>
 <p:notes xmlns:a="http://schemas.openxmlformats.org/drawingml/2006/main" xmlns:r="http://schemas.openxmlformats.org/officeDocument/2006/relationships" xmlns:p="http://schemas.openxmlformats.org/presentationml/2006/main">
   <p:cSld>
@@ -1193,6 +1336,76 @@
         <p14:creationId xmlns:p14="http://schemas.microsoft.com/office/powerpoint/2010/main" val="1024086991"/>
       </p:ext>
     </p:extLst>
+  </p:cSld>
+  <p:clrMapOvr>
+    <a:masterClrMapping/>
+  </p:clrMapOvr>
+</p:notes>
+</file>
+
+<file path=ppt/notesSlides/notesSlide9.xml><?xml version="1.0" encoding="utf-8"?>
+<p:notes xmlns:a="http://schemas.openxmlformats.org/drawingml/2006/main" xmlns:p="http://schemas.openxmlformats.org/presentationml/2006/main" xmlns:r="http://schemas.openxmlformats.org/officeDocument/2006/relationships">
+  <p:cSld>
+    <p:spTree>
+      <p:nvGrpSpPr>
+        <p:cNvPr id="1" name=""/>
+        <p:cNvGrpSpPr/>
+        <p:nvPr/>
+      </p:nvGrpSpPr>
+      <p:grpSpPr>
+        <a:xfrm>
+          <a:off x="0" y="0"/>
+          <a:ext cx="0" cy="0"/>
+          <a:chOff x="0" y="0"/>
+          <a:chExt cx="0" cy="0"/>
+        </a:xfrm>
+      </p:grpSpPr>
+      <p:sp>
+        <p:nvSpPr>
+          <p:cNvPr id="2" name="Slide Image Placeholder 1"/>
+          <p:cNvSpPr>
+            <a:spLocks noGrp="1"/>
+          </p:cNvSpPr>
+          <p:nvPr>
+            <p:ph type="sldImg" idx="2"/>
+          </p:nvPr>
+        </p:nvSpPr>
+        <p:spPr/>
+      </p:sp>
+      <p:sp>
+        <p:nvSpPr>
+          <p:cNvPr id="3" name="Notes Placeholder 2"/>
+          <p:cNvSpPr>
+            <a:spLocks noGrp="1"/>
+          </p:cNvSpPr>
+          <p:nvPr>
+            <p:ph type="body" idx="3" sz="quarter"/>
+          </p:nvPr>
+        </p:nvSpPr>
+        <p:spPr/>
+        <p:txBody>
+          <a:bodyPr/>
+          <a:lstStyle/>
+          <a:p>
+            <a:r>
+              <a:t>Left: the original Notion page in the test workspace. Right: the same page in the dashboard after downloading, with its date, people, topics and follow-ups, tagged NOTION.</a:t>
+            </a:r>
+          </a:p>
+        </p:txBody>
+      </p:sp>
+      <p:sp>
+        <p:nvSpPr>
+          <p:cNvPr id="4" name="Slide Number Placeholder 3"/>
+          <p:cNvSpPr>
+            <a:spLocks noGrp="1"/>
+          </p:cNvSpPr>
+          <p:nvPr>
+            <p:ph type="sldNum" idx="5" sz="quarter"/>
+          </p:nvPr>
+        </p:nvSpPr>
+        <p:spPr/>
+      </p:sp>
+    </p:spTree>
   </p:cSld>
   <p:clrMapOvr>
     <a:masterClrMapping/>
@@ -1895,6 +2108,651 @@
 </p:sld>
 </file>
 
+<file path=ppt/slides/slide10.xml><?xml version="1.0" encoding="utf-8"?>
+<p:sld xmlns:a="http://schemas.openxmlformats.org/drawingml/2006/main" xmlns:r="http://schemas.openxmlformats.org/officeDocument/2006/relationships" xmlns:p="http://schemas.openxmlformats.org/presentationml/2006/main">
+  <p:cSld name="Slide 7">
+    <p:spTree>
+      <p:nvGrpSpPr>
+        <p:cNvPr id="1" name=""/>
+        <p:cNvGrpSpPr/>
+        <p:nvPr/>
+      </p:nvGrpSpPr>
+      <p:grpSpPr>
+        <a:xfrm>
+          <a:off x="0" y="0"/>
+          <a:ext cx="0" cy="0"/>
+          <a:chOff x="0" y="0"/>
+          <a:chExt cx="0" cy="0"/>
+        </a:xfrm>
+      </p:grpSpPr>
+      <p:sp>
+        <p:nvSpPr>
+          <p:cNvPr id="2" name="Text 0"/>
+          <p:cNvSpPr/>
+          <p:nvPr>
+            <p:ph idx="100" type="title" hasCustomPrompt="1"/>
+          </p:nvPr>
+        </p:nvSpPr>
+        <p:spPr>
+          <a:xfrm>
+            <a:off x="457200" y="274320"/>
+            <a:ext cx="8229600" cy="685800"/>
+          </a:xfrm>
+          <a:prstGeom prst="rect">
+            <a:avLst/>
+          </a:prstGeom>
+          <a:noFill/>
+          <a:ln/>
+        </p:spPr>
+        <p:txBody>
+          <a:bodyPr wrap="square" lIns="0" tIns="0" rIns="0" bIns="0" rtlCol="0" anchor="ctr"/>
+          <a:lstStyle/>
+          <a:p>
+            <a:pPr indent="0" marL="0">
+              <a:buNone/>
+            </a:pPr>
+            <a:r>
+              <a:rPr lang="en-US" sz="3000" b="1" dirty="0">
+                <a:solidFill>
+                  <a:schemeClr val="tx1"/>
+                </a:solidFill>
+              </a:rPr>
+              <a:t>Secure by default, easy to extend</a:t>
+            </a:r>
+            <a:endParaRPr lang="en-US" sz="3000" dirty="0"/>
+          </a:p>
+        </p:txBody>
+      </p:sp>
+      <p:sp>
+        <p:nvSpPr>
+          <p:cNvPr id="3" name="Shape 1"/>
+          <p:cNvSpPr/>
+          <p:nvPr/>
+        </p:nvSpPr>
+        <p:spPr>
+          <a:xfrm>
+            <a:off x="457200" y="1188720"/>
+            <a:ext cx="4023360" cy="3383280"/>
+          </a:xfrm>
+          <a:prstGeom prst="roundRect">
+            <a:avLst>
+              <a:gd name="adj" fmla="val 3243"/>
+            </a:avLst>
+          </a:prstGeom>
+          <a:solidFill>
+            <a:schemeClr val="bg2"/>
+          </a:solidFill>
+          <a:ln/>
+        </p:spPr>
+      </p:sp>
+      <p:sp>
+        <p:nvSpPr>
+          <p:cNvPr id="4" name="Shape 2"/>
+          <p:cNvSpPr/>
+          <p:nvPr/>
+        </p:nvSpPr>
+        <p:spPr>
+          <a:xfrm>
+            <a:off x="731520" y="1371600"/>
+            <a:ext cx="502920" cy="502920"/>
+          </a:xfrm>
+          <a:prstGeom prst="ellipse">
+            <a:avLst/>
+          </a:prstGeom>
+          <a:solidFill>
+            <a:schemeClr val="accent1"/>
+          </a:solidFill>
+          <a:ln/>
+        </p:spPr>
+      </p:sp>
+      <p:sp>
+        <p:nvSpPr>
+          <p:cNvPr id="5" name="Text 3"/>
+          <p:cNvSpPr txBox="1"/>
+          <p:nvPr/>
+        </p:nvSpPr>
+        <p:spPr>
+          <a:xfrm>
+            <a:off x="731520" y="1371600"/>
+            <a:ext cx="502920" cy="502920"/>
+          </a:xfrm>
+          <a:prstGeom prst="rect">
+            <a:avLst/>
+          </a:prstGeom>
+          <a:noFill/>
+          <a:ln/>
+        </p:spPr>
+        <p:txBody>
+          <a:bodyPr wrap="square" lIns="0" tIns="0" rIns="0" bIns="0" rtlCol="0" anchor="ctr"/>
+          <a:lstStyle/>
+          <a:p>
+            <a:pPr algn="ctr" indent="0" marL="0">
+              <a:buNone/>
+            </a:pPr>
+            <a:r>
+              <a:rPr lang="en-US" sz="2000" b="1" dirty="0">
+                <a:solidFill>
+                  <a:schemeClr val="bg1"/>
+                </a:solidFill>
+              </a:rPr>
+              <a:t>✓</a:t>
+            </a:r>
+            <a:endParaRPr lang="en-US" sz="2000" dirty="0"/>
+          </a:p>
+        </p:txBody>
+      </p:sp>
+      <p:sp>
+        <p:nvSpPr>
+          <p:cNvPr id="6" name="Text 4"/>
+          <p:cNvSpPr txBox="1"/>
+          <p:nvPr/>
+        </p:nvSpPr>
+        <p:spPr>
+          <a:xfrm>
+            <a:off x="1371600" y="1417320"/>
+            <a:ext cx="2926080" cy="411480"/>
+          </a:xfrm>
+          <a:prstGeom prst="rect">
+            <a:avLst/>
+          </a:prstGeom>
+          <a:noFill/>
+          <a:ln/>
+        </p:spPr>
+        <p:txBody>
+          <a:bodyPr wrap="square" lIns="0" tIns="0" rIns="0" bIns="0" rtlCol="0" anchor="ctr"/>
+          <a:lstStyle/>
+          <a:p>
+            <a:pPr indent="0" marL="0">
+              <a:buNone/>
+            </a:pPr>
+            <a:r>
+              <a:rPr lang="en-US" sz="2000" b="1" dirty="0">
+                <a:solidFill>
+                  <a:schemeClr val="tx1"/>
+                </a:solidFill>
+                <a:latin typeface="Cambria" pitchFamily="34" charset="0"/>
+                <a:ea typeface="Cambria" pitchFamily="34" charset="-122"/>
+                <a:cs typeface="Cambria" pitchFamily="34" charset="-120"/>
+              </a:rPr>
+              <a:t>Security</a:t>
+            </a:r>
+            <a:endParaRPr lang="en-US" sz="2000" dirty="0"/>
+          </a:p>
+        </p:txBody>
+      </p:sp>
+      <p:sp>
+        <p:nvSpPr>
+          <p:cNvPr id="7" name="Text 5"/>
+          <p:cNvSpPr txBox="1"/>
+          <p:nvPr/>
+        </p:nvSpPr>
+        <p:spPr>
+          <a:xfrm>
+            <a:off x="731520" y="2057400"/>
+            <a:ext cx="3566160" cy="2377440"/>
+          </a:xfrm>
+          <a:prstGeom prst="rect">
+            <a:avLst/>
+          </a:prstGeom>
+          <a:noFill/>
+          <a:ln/>
+        </p:spPr>
+        <p:txBody>
+          <a:bodyPr wrap="square" rtlCol="0" anchor="t"/>
+          <a:lstStyle/>
+          <a:p>
+            <a:pPr marL="342900" indent="-342900">
+              <a:spcAft>
+                <a:spcPts val="800"/>
+              </a:spcAft>
+              <a:buSzPct val="100000"/>
+              <a:buChar char="•"/>
+            </a:pPr>
+            <a:r>
+              <a:rPr lang="en-US" sz="1400" dirty="0">
+                <a:solidFill>
+                  <a:schemeClr val="tx2"/>
+                </a:solidFill>
+              </a:rPr>
+              <a:t>OAuth tokens live in the OS keychain, managed by Claude Code</a:t>
+            </a:r>
+            <a:endParaRPr lang="en-US" sz="1400" dirty="0"/>
+          </a:p>
+          <a:p>
+            <a:pPr marL="342900" indent="-342900">
+              <a:spcAft>
+                <a:spcPts val="800"/>
+              </a:spcAft>
+              <a:buSzPct val="100000"/>
+              <a:buChar char="•"/>
+            </a:pPr>
+            <a:r>
+              <a:rPr lang="en-US" sz="1400" dirty="0">
+                <a:solidFill>
+                  <a:schemeClr val="tx2"/>
+                </a:solidFill>
+              </a:rPr>
+              <a:t>GitHub token comes from the GITHUB_PAT environment variable</a:t>
+            </a:r>
+            <a:endParaRPr lang="en-US" sz="1400" dirty="0"/>
+          </a:p>
+          <a:p>
+            <a:pPr marL="342900" indent="-342900">
+              <a:spcAft>
+                <a:spcPts val="800"/>
+              </a:spcAft>
+              <a:buSzPct val="100000"/>
+              <a:buChar char="•"/>
+            </a:pPr>
+            <a:r>
+              <a:rPr lang="en-US" sz="1400" dirty="0">
+                <a:solidFill>
+                  <a:schemeClr val="tx2"/>
+                </a:solidFill>
+              </a:rPr>
+              <a:t>.gitignore blocks .env, credentials and token files</a:t>
+            </a:r>
+            <a:endParaRPr lang="en-US" sz="1400" dirty="0"/>
+          </a:p>
+          <a:p>
+            <a:pPr marL="342900" indent="-342900">
+              <a:spcAft>
+                <a:spcPts val="800"/>
+              </a:spcAft>
+              <a:buSzPct val="100000"/>
+              <a:buChar char="•"/>
+            </a:pPr>
+            <a:r>
+              <a:rPr lang="en-US" sz="1400" dirty="0">
+                <a:solidFill>
+                  <a:schemeClr val="tx2"/>
+                </a:solidFill>
+              </a:rPr>
+              <a:t>Only test accounts and fictional data</a:t>
+            </a:r>
+            <a:endParaRPr lang="en-US" sz="1400" dirty="0"/>
+          </a:p>
+        </p:txBody>
+      </p:sp>
+      <p:sp>
+        <p:nvSpPr>
+          <p:cNvPr id="8" name="Shape 6"/>
+          <p:cNvSpPr/>
+          <p:nvPr/>
+        </p:nvSpPr>
+        <p:spPr>
+          <a:xfrm>
+            <a:off x="4663440" y="1188720"/>
+            <a:ext cx="4023360" cy="3383280"/>
+          </a:xfrm>
+          <a:prstGeom prst="roundRect">
+            <a:avLst>
+              <a:gd name="adj" fmla="val 3243"/>
+            </a:avLst>
+          </a:prstGeom>
+          <a:solidFill>
+            <a:schemeClr val="bg2"/>
+          </a:solidFill>
+          <a:ln/>
+        </p:spPr>
+      </p:sp>
+      <p:sp>
+        <p:nvSpPr>
+          <p:cNvPr id="9" name="Shape 7"/>
+          <p:cNvSpPr/>
+          <p:nvPr/>
+        </p:nvSpPr>
+        <p:spPr>
+          <a:xfrm>
+            <a:off x="4937760" y="1371600"/>
+            <a:ext cx="502920" cy="502920"/>
+          </a:xfrm>
+          <a:prstGeom prst="ellipse">
+            <a:avLst/>
+          </a:prstGeom>
+          <a:solidFill>
+            <a:schemeClr val="accent2"/>
+          </a:solidFill>
+          <a:ln/>
+        </p:spPr>
+      </p:sp>
+      <p:sp>
+        <p:nvSpPr>
+          <p:cNvPr id="10" name="Text 8"/>
+          <p:cNvSpPr txBox="1"/>
+          <p:nvPr/>
+        </p:nvSpPr>
+        <p:spPr>
+          <a:xfrm>
+            <a:off x="4937760" y="1371600"/>
+            <a:ext cx="502920" cy="502920"/>
+          </a:xfrm>
+          <a:prstGeom prst="rect">
+            <a:avLst/>
+          </a:prstGeom>
+          <a:noFill/>
+          <a:ln/>
+        </p:spPr>
+        <p:txBody>
+          <a:bodyPr wrap="square" lIns="0" tIns="0" rIns="0" bIns="0" rtlCol="0" anchor="ctr"/>
+          <a:lstStyle/>
+          <a:p>
+            <a:pPr algn="ctr" indent="0" marL="0">
+              <a:buNone/>
+            </a:pPr>
+            <a:r>
+              <a:rPr lang="en-US" sz="2000" b="1" dirty="0">
+                <a:solidFill>
+                  <a:schemeClr val="bg1"/>
+                </a:solidFill>
+              </a:rPr>
+              <a:t>+</a:t>
+            </a:r>
+            <a:endParaRPr lang="en-US" sz="2000" dirty="0"/>
+          </a:p>
+        </p:txBody>
+      </p:sp>
+      <p:sp>
+        <p:nvSpPr>
+          <p:cNvPr id="11" name="Text 9"/>
+          <p:cNvSpPr txBox="1"/>
+          <p:nvPr/>
+        </p:nvSpPr>
+        <p:spPr>
+          <a:xfrm>
+            <a:off x="5577840" y="1417320"/>
+            <a:ext cx="2926080" cy="411480"/>
+          </a:xfrm>
+          <a:prstGeom prst="rect">
+            <a:avLst/>
+          </a:prstGeom>
+          <a:noFill/>
+          <a:ln/>
+        </p:spPr>
+        <p:txBody>
+          <a:bodyPr wrap="square" lIns="0" tIns="0" rIns="0" bIns="0" rtlCol="0" anchor="ctr"/>
+          <a:lstStyle/>
+          <a:p>
+            <a:pPr indent="0" marL="0">
+              <a:buNone/>
+            </a:pPr>
+            <a:r>
+              <a:rPr lang="en-US" sz="2000" b="1" dirty="0">
+                <a:solidFill>
+                  <a:schemeClr val="tx1"/>
+                </a:solidFill>
+                <a:latin typeface="Cambria" pitchFamily="34" charset="0"/>
+                <a:ea typeface="Cambria" pitchFamily="34" charset="-122"/>
+                <a:cs typeface="Cambria" pitchFamily="34" charset="-120"/>
+              </a:rPr>
+              <a:t>Adding a service</a:t>
+            </a:r>
+            <a:endParaRPr lang="en-US" sz="2000" dirty="0"/>
+          </a:p>
+        </p:txBody>
+      </p:sp>
+      <p:sp>
+        <p:nvSpPr>
+          <p:cNvPr id="12" name="Text 10"/>
+          <p:cNvSpPr txBox="1"/>
+          <p:nvPr/>
+        </p:nvSpPr>
+        <p:spPr>
+          <a:xfrm>
+            <a:off x="4937760" y="2057400"/>
+            <a:ext cx="3566160" cy="2377440"/>
+          </a:xfrm>
+          <a:prstGeom prst="rect">
+            <a:avLst/>
+          </a:prstGeom>
+          <a:noFill/>
+          <a:ln/>
+        </p:spPr>
+        <p:txBody>
+          <a:bodyPr wrap="square" rtlCol="0" anchor="t"/>
+          <a:lstStyle/>
+          <a:p>
+            <a:pPr marL="342900" indent="-342900">
+              <a:spcAft>
+                <a:spcPts val="800"/>
+              </a:spcAft>
+              <a:buSzPct val="100000"/>
+              <a:buChar char="•"/>
+            </a:pPr>
+            <a:r>
+              <a:rPr lang="en-US" sz="1400" dirty="0">
+                <a:solidFill>
+                  <a:schemeClr val="tx2"/>
+                </a:solidFill>
+              </a:rPr>
+              <a:t>Add its official MCP server to .mcp.json</a:t>
+            </a:r>
+            <a:endParaRPr lang="en-US" sz="1400" dirty="0"/>
+          </a:p>
+          <a:p>
+            <a:pPr marL="342900" indent="-342900">
+              <a:spcAft>
+                <a:spcPts val="800"/>
+              </a:spcAft>
+              <a:buSzPct val="100000"/>
+              <a:buChar char="•"/>
+            </a:pPr>
+            <a:r>
+              <a:rPr lang="en-US" sz="1400" dirty="0">
+                <a:solidFill>
+                  <a:schemeClr val="tx2"/>
+                </a:solidFill>
+              </a:rPr>
+              <a:t>Add a section to localStorageFormats.md</a:t>
+            </a:r>
+            <a:endParaRPr lang="en-US" sz="1400" dirty="0"/>
+          </a:p>
+          <a:p>
+            <a:pPr marL="342900" indent="-342900">
+              <a:spcAft>
+                <a:spcPts val="800"/>
+              </a:spcAft>
+              <a:buSzPct val="100000"/>
+              <a:buChar char="•"/>
+            </a:pPr>
+            <a:r>
+              <a:rPr lang="en-US" sz="1400" dirty="0">
+                <a:solidFill>
+                  <a:schemeClr val="tx2"/>
+                </a:solidFill>
+              </a:rPr>
+              <a:t>Add a download-&lt;service&gt; skill</a:t>
+            </a:r>
+            <a:endParaRPr lang="en-US" sz="1400" dirty="0"/>
+          </a:p>
+          <a:p>
+            <a:pPr marL="342900" indent="-342900">
+              <a:spcAft>
+                <a:spcPts val="800"/>
+              </a:spcAft>
+              <a:buSzPct val="100000"/>
+              <a:buChar char="•"/>
+            </a:pPr>
+            <a:r>
+              <a:rPr lang="en-US" sz="1400" dirty="0">
+                <a:solidFill>
+                  <a:schemeClr val="tx2"/>
+                </a:solidFill>
+              </a:rPr>
+              <a:t>Save with save_export.py; the dashboard picks it up</a:t>
+            </a:r>
+            <a:endParaRPr lang="en-US" sz="1400" dirty="0"/>
+          </a:p>
+        </p:txBody>
+      </p:sp>
+      <p:sp>
+        <p:nvSpPr>
+          <p:cNvPr id="25" name="Slide Number Placeholder 0"/>
+          <p:cNvSpPr>
+            <a:spLocks noGrp="1"/>
+          </p:cNvSpPr>
+          <p:nvPr>
+            <p:ph type="sldNum" sz="quarter" idx="4294967295"/>
+          </p:nvPr>
+        </p:nvSpPr>
+        <p:spPr>
+          <a:xfrm>
+            <a:off x="8412480" y="4754880"/>
+            <a:ext cx="457200" cy="274320"/>
+          </a:xfrm>
+          <a:prstGeom prst="rect">
+            <a:avLst/>
+          </a:prstGeom>
+          <a:extLst>
+            <a:ext uri="{C572A759-6A51-4108-AA02-DFA0A04FC94B}">
+              <ma14:wrappingTextBoxFlag xmlns:ma14="http://schemas.microsoft.com/office/mac/drawingml/2011/main" val="0"/>
+            </a:ext>
+          </a:extLst>
+        </p:spPr>
+        <p:txBody>
+          <a:bodyPr/>
+          <a:lstStyle>
+            <a:lvl1pPr>
+              <a:defRPr sz="1000">
+                <a:solidFill>
+                  <a:schemeClr val="accent3"/>
+                </a:solidFill>
+              </a:defRPr>
+            </a:lvl1pPr>
+          </a:lstStyle>
+          <a:p>
+            <a:pPr algn="l"/>
+            <a:fld id="{F7021451-1387-4CA6-816F-3879F97B5CBC}" type="slidenum">
+              <a:rPr b="0" lang="en-US"/>
+              <a:t>7</a:t>
+            </a:fld>
+            <a:endParaRPr lang="en-US"/>
+          </a:p>
+        </p:txBody>
+      </p:sp>
+    </p:spTree>
+  </p:cSld>
+  <p:clrMapOvr>
+    <a:masterClrMapping/>
+  </p:clrMapOvr>
+</p:sld>
+</file>
+
+<file path=ppt/slides/slide11.xml><?xml version="1.0" encoding="utf-8"?>
+<p:sld xmlns:a="http://schemas.openxmlformats.org/drawingml/2006/main" xmlns:r="http://schemas.openxmlformats.org/officeDocument/2006/relationships" xmlns:p="http://schemas.openxmlformats.org/presentationml/2006/main">
+  <p:cSld name="Slide 8">
+    <p:spTree>
+      <p:nvGrpSpPr>
+        <p:cNvPr id="1" name=""/>
+        <p:cNvGrpSpPr/>
+        <p:nvPr/>
+      </p:nvGrpSpPr>
+      <p:grpSpPr>
+        <a:xfrm>
+          <a:off x="0" y="0"/>
+          <a:ext cx="0" cy="0"/>
+          <a:chOff x="0" y="0"/>
+          <a:chExt cx="0" cy="0"/>
+        </a:xfrm>
+      </p:grpSpPr>
+      <p:sp>
+        <p:nvSpPr>
+          <p:cNvPr id="2" name="Text 0"/>
+          <p:cNvSpPr/>
+          <p:nvPr>
+            <p:ph idx="100" type="title" hasCustomPrompt="1"/>
+          </p:nvPr>
+        </p:nvSpPr>
+        <p:spPr>
+          <a:xfrm>
+            <a:off x="548640" y="1371600"/>
+            <a:ext cx="8046720" cy="1188720"/>
+          </a:xfrm>
+          <a:prstGeom prst="rect">
+            <a:avLst/>
+          </a:prstGeom>
+          <a:noFill/>
+          <a:ln/>
+        </p:spPr>
+        <p:txBody>
+          <a:bodyPr wrap="square" rtlCol="0" anchor="b"/>
+          <a:lstStyle/>
+          <a:p>
+            <a:pPr indent="0" marL="0">
+              <a:buNone/>
+            </a:pPr>
+            <a:r>
+              <a:rPr lang="en-US" sz="4000" b="1" dirty="0">
+                <a:solidFill>
+                  <a:schemeClr val="bg1"/>
+                </a:solidFill>
+              </a:rPr>
+              <a:t>Thank you</a:t>
+            </a:r>
+            <a:endParaRPr lang="en-US" sz="4000" dirty="0"/>
+          </a:p>
+        </p:txBody>
+      </p:sp>
+      <p:sp>
+        <p:nvSpPr>
+          <p:cNvPr id="3" name="Text 0"/>
+          <p:cNvSpPr/>
+          <p:nvPr>
+            <p:ph idx="101" type="body" hasCustomPrompt="1"/>
+          </p:nvPr>
+        </p:nvSpPr>
+        <p:spPr>
+          <a:xfrm>
+            <a:off x="548640" y="2697480"/>
+            <a:ext cx="8046720" cy="1097280"/>
+          </a:xfrm>
+          <a:prstGeom prst="rect">
+            <a:avLst/>
+          </a:prstGeom>
+          <a:noFill/>
+          <a:ln/>
+        </p:spPr>
+        <p:txBody>
+          <a:bodyPr wrap="square" rtlCol="0" anchor="t"/>
+          <a:lstStyle/>
+          <a:p>
+            <a:pPr indent="0" marL="0">
+              <a:buNone/>
+            </a:pPr>
+            <a:r>
+              <a:rPr lang="en-US" sz="1800" dirty="0">
+                <a:solidFill>
+                  <a:schemeClr val="accent4"/>
+                </a:solidFill>
+              </a:rPr>
+              <a:t>Questions?</a:t>
+            </a:r>
+            <a:endParaRPr lang="en-US" sz="1800" dirty="0"/>
+          </a:p>
+          <a:p>
+            <a:pPr indent="0" marL="0">
+              <a:buNone/>
+            </a:pPr>
+            <a:r>
+              <a:rPr lang="en-US" sz="1800" dirty="0">
+                <a:solidFill>
+                  <a:schemeClr val="accent4"/>
+                </a:solidFill>
+              </a:rPr>
+              <a:t>github.com/nyohayon-jpg/hw-services-dashboard</a:t>
+            </a:r>
+            <a:endParaRPr lang="en-US" sz="1800" dirty="0"/>
+          </a:p>
+        </p:txBody>
+      </p:sp>
+    </p:spTree>
+  </p:cSld>
+  <p:clrMapOvr>
+    <a:masterClrMapping/>
+  </p:clrMapOvr>
+</p:sld>
+</file>
+
 <file path=ppt/slides/slide2.xml><?xml version="1.0" encoding="utf-8"?>
 <p:sld xmlns:a="http://schemas.openxmlformats.org/drawingml/2006/main" xmlns:r="http://schemas.openxmlformats.org/officeDocument/2006/relationships" xmlns:p="http://schemas.openxmlformats.org/presentationml/2006/main">
   <p:cSld name="Slide 2">
@@ -5010,524 +5868,186 @@
 </file>
 
 <file path=ppt/slides/slide7.xml><?xml version="1.0" encoding="utf-8"?>
-<p:sld xmlns:a="http://schemas.openxmlformats.org/drawingml/2006/main" xmlns:r="http://schemas.openxmlformats.org/officeDocument/2006/relationships" xmlns:p="http://schemas.openxmlformats.org/presentationml/2006/main">
-  <p:cSld name="Slide 7">
+<p:sld xmlns:a="http://schemas.openxmlformats.org/drawingml/2006/main" xmlns:p="http://schemas.openxmlformats.org/presentationml/2006/main" xmlns:r="http://schemas.openxmlformats.org/officeDocument/2006/relationships">
+  <p:cSld>
     <p:spTree>
       <p:nvGrpSpPr>
         <p:cNvPr id="1" name=""/>
         <p:cNvGrpSpPr/>
         <p:nvPr/>
       </p:nvGrpSpPr>
-      <p:grpSpPr>
-        <a:xfrm>
-          <a:off x="0" y="0"/>
-          <a:ext cx="0" cy="0"/>
-          <a:chOff x="0" y="0"/>
-          <a:chExt cx="0" cy="0"/>
-        </a:xfrm>
-      </p:grpSpPr>
-      <p:sp>
-        <p:nvSpPr>
-          <p:cNvPr id="2" name="Text 0"/>
-          <p:cNvSpPr/>
-          <p:nvPr>
-            <p:ph idx="100" type="title" hasCustomPrompt="1"/>
-          </p:nvPr>
-        </p:nvSpPr>
-        <p:spPr>
-          <a:xfrm>
-            <a:off x="457200" y="274320"/>
-            <a:ext cx="8229600" cy="685800"/>
-          </a:xfrm>
-          <a:prstGeom prst="rect">
-            <a:avLst/>
-          </a:prstGeom>
-          <a:noFill/>
-          <a:ln/>
-        </p:spPr>
-        <p:txBody>
-          <a:bodyPr wrap="square" lIns="0" tIns="0" rIns="0" bIns="0" rtlCol="0" anchor="ctr"/>
-          <a:lstStyle/>
-          <a:p>
-            <a:pPr indent="0" marL="0">
-              <a:buNone/>
-            </a:pPr>
-            <a:r>
-              <a:rPr lang="en-US" sz="3000" b="1" dirty="0">
-                <a:solidFill>
-                  <a:schemeClr val="tx1"/>
-                </a:solidFill>
-              </a:rPr>
-              <a:t>Secure by default, easy to extend</a:t>
-            </a:r>
-            <a:endParaRPr lang="en-US" sz="3000" dirty="0"/>
-          </a:p>
-        </p:txBody>
-      </p:sp>
-      <p:sp>
-        <p:nvSpPr>
-          <p:cNvPr id="3" name="Shape 1"/>
-          <p:cNvSpPr/>
-          <p:nvPr/>
-        </p:nvSpPr>
-        <p:spPr>
-          <a:xfrm>
-            <a:off x="457200" y="1188720"/>
-            <a:ext cx="4023360" cy="3383280"/>
-          </a:xfrm>
-          <a:prstGeom prst="roundRect">
-            <a:avLst>
-              <a:gd name="adj" fmla="val 3243"/>
-            </a:avLst>
-          </a:prstGeom>
-          <a:solidFill>
-            <a:schemeClr val="bg2"/>
-          </a:solidFill>
-          <a:ln/>
-        </p:spPr>
-      </p:sp>
-      <p:sp>
-        <p:nvSpPr>
-          <p:cNvPr id="4" name="Shape 2"/>
-          <p:cNvSpPr/>
-          <p:nvPr/>
-        </p:nvSpPr>
-        <p:spPr>
-          <a:xfrm>
-            <a:off x="731520" y="1371600"/>
-            <a:ext cx="502920" cy="502920"/>
-          </a:xfrm>
-          <a:prstGeom prst="ellipse">
-            <a:avLst/>
-          </a:prstGeom>
-          <a:solidFill>
-            <a:schemeClr val="accent1"/>
-          </a:solidFill>
-          <a:ln/>
-        </p:spPr>
-      </p:sp>
-      <p:sp>
-        <p:nvSpPr>
-          <p:cNvPr id="5" name="Text 3"/>
-          <p:cNvSpPr txBox="1"/>
-          <p:nvPr/>
-        </p:nvSpPr>
-        <p:spPr>
-          <a:xfrm>
-            <a:off x="731520" y="1371600"/>
-            <a:ext cx="502920" cy="502920"/>
-          </a:xfrm>
-          <a:prstGeom prst="rect">
-            <a:avLst/>
-          </a:prstGeom>
-          <a:noFill/>
-          <a:ln/>
-        </p:spPr>
-        <p:txBody>
-          <a:bodyPr wrap="square" lIns="0" tIns="0" rIns="0" bIns="0" rtlCol="0" anchor="ctr"/>
-          <a:lstStyle/>
-          <a:p>
-            <a:pPr algn="ctr" indent="0" marL="0">
-              <a:buNone/>
-            </a:pPr>
-            <a:r>
-              <a:rPr lang="en-US" sz="2000" b="1" dirty="0">
-                <a:solidFill>
-                  <a:schemeClr val="bg1"/>
-                </a:solidFill>
-              </a:rPr>
-              <a:t>✓</a:t>
-            </a:r>
-            <a:endParaRPr lang="en-US" sz="2000" dirty="0"/>
-          </a:p>
-        </p:txBody>
-      </p:sp>
-      <p:sp>
-        <p:nvSpPr>
-          <p:cNvPr id="6" name="Text 4"/>
-          <p:cNvSpPr txBox="1"/>
-          <p:nvPr/>
-        </p:nvSpPr>
-        <p:spPr>
-          <a:xfrm>
-            <a:off x="1371600" y="1417320"/>
-            <a:ext cx="2926080" cy="411480"/>
-          </a:xfrm>
-          <a:prstGeom prst="rect">
-            <a:avLst/>
-          </a:prstGeom>
-          <a:noFill/>
-          <a:ln/>
-        </p:spPr>
-        <p:txBody>
-          <a:bodyPr wrap="square" lIns="0" tIns="0" rIns="0" bIns="0" rtlCol="0" anchor="ctr"/>
-          <a:lstStyle/>
-          <a:p>
-            <a:pPr indent="0" marL="0">
-              <a:buNone/>
-            </a:pPr>
-            <a:r>
-              <a:rPr lang="en-US" sz="2000" b="1" dirty="0">
-                <a:solidFill>
-                  <a:schemeClr val="tx1"/>
-                </a:solidFill>
-                <a:latin typeface="Cambria" pitchFamily="34" charset="0"/>
-                <a:ea typeface="Cambria" pitchFamily="34" charset="-122"/>
-                <a:cs typeface="Cambria" pitchFamily="34" charset="-120"/>
-              </a:rPr>
-              <a:t>Security</a:t>
-            </a:r>
-            <a:endParaRPr lang="en-US" sz="2000" dirty="0"/>
-          </a:p>
-        </p:txBody>
-      </p:sp>
-      <p:sp>
-        <p:nvSpPr>
-          <p:cNvPr id="7" name="Text 5"/>
-          <p:cNvSpPr txBox="1"/>
-          <p:nvPr/>
-        </p:nvSpPr>
-        <p:spPr>
-          <a:xfrm>
-            <a:off x="731520" y="2057400"/>
-            <a:ext cx="3566160" cy="2377440"/>
-          </a:xfrm>
-          <a:prstGeom prst="rect">
-            <a:avLst/>
-          </a:prstGeom>
-          <a:noFill/>
-          <a:ln/>
-        </p:spPr>
-        <p:txBody>
-          <a:bodyPr wrap="square" rtlCol="0" anchor="t"/>
-          <a:lstStyle/>
-          <a:p>
-            <a:pPr marL="342900" indent="-342900">
-              <a:spcAft>
-                <a:spcPts val="800"/>
-              </a:spcAft>
-              <a:buSzPct val="100000"/>
-              <a:buChar char="•"/>
-            </a:pPr>
-            <a:r>
-              <a:rPr lang="en-US" sz="1400" dirty="0">
-                <a:solidFill>
-                  <a:schemeClr val="tx2"/>
-                </a:solidFill>
-              </a:rPr>
-              <a:t>OAuth tokens live in the OS keychain, managed by Claude Code</a:t>
-            </a:r>
-            <a:endParaRPr lang="en-US" sz="1400" dirty="0"/>
-          </a:p>
-          <a:p>
-            <a:pPr marL="342900" indent="-342900">
-              <a:spcAft>
-                <a:spcPts val="800"/>
-              </a:spcAft>
-              <a:buSzPct val="100000"/>
-              <a:buChar char="•"/>
-            </a:pPr>
-            <a:r>
-              <a:rPr lang="en-US" sz="1400" dirty="0">
-                <a:solidFill>
-                  <a:schemeClr val="tx2"/>
-                </a:solidFill>
-              </a:rPr>
-              <a:t>GitHub token comes from the GITHUB_PAT environment variable</a:t>
-            </a:r>
-            <a:endParaRPr lang="en-US" sz="1400" dirty="0"/>
-          </a:p>
-          <a:p>
-            <a:pPr marL="342900" indent="-342900">
-              <a:spcAft>
-                <a:spcPts val="800"/>
-              </a:spcAft>
-              <a:buSzPct val="100000"/>
-              <a:buChar char="•"/>
-            </a:pPr>
-            <a:r>
-              <a:rPr lang="en-US" sz="1400" dirty="0">
-                <a:solidFill>
-                  <a:schemeClr val="tx2"/>
-                </a:solidFill>
-              </a:rPr>
-              <a:t>.gitignore blocks .env, credentials and token files</a:t>
-            </a:r>
-            <a:endParaRPr lang="en-US" sz="1400" dirty="0"/>
-          </a:p>
-          <a:p>
-            <a:pPr marL="342900" indent="-342900">
-              <a:spcAft>
-                <a:spcPts val="800"/>
-              </a:spcAft>
-              <a:buSzPct val="100000"/>
-              <a:buChar char="•"/>
-            </a:pPr>
-            <a:r>
-              <a:rPr lang="en-US" sz="1400" dirty="0">
-                <a:solidFill>
-                  <a:schemeClr val="tx2"/>
-                </a:solidFill>
-              </a:rPr>
-              <a:t>Only test accounts and fictional data</a:t>
-            </a:r>
-            <a:endParaRPr lang="en-US" sz="1400" dirty="0"/>
-          </a:p>
-        </p:txBody>
-      </p:sp>
-      <p:sp>
-        <p:nvSpPr>
-          <p:cNvPr id="8" name="Shape 6"/>
-          <p:cNvSpPr/>
-          <p:nvPr/>
-        </p:nvSpPr>
-        <p:spPr>
-          <a:xfrm>
-            <a:off x="4663440" y="1188720"/>
-            <a:ext cx="4023360" cy="3383280"/>
-          </a:xfrm>
-          <a:prstGeom prst="roundRect">
-            <a:avLst>
-              <a:gd name="adj" fmla="val 3243"/>
-            </a:avLst>
-          </a:prstGeom>
-          <a:solidFill>
-            <a:schemeClr val="bg2"/>
-          </a:solidFill>
-          <a:ln/>
-        </p:spPr>
-      </p:sp>
-      <p:sp>
-        <p:nvSpPr>
-          <p:cNvPr id="9" name="Shape 7"/>
-          <p:cNvSpPr/>
-          <p:nvPr/>
-        </p:nvSpPr>
-        <p:spPr>
-          <a:xfrm>
-            <a:off x="4937760" y="1371600"/>
-            <a:ext cx="502920" cy="502920"/>
-          </a:xfrm>
-          <a:prstGeom prst="ellipse">
-            <a:avLst/>
-          </a:prstGeom>
-          <a:solidFill>
-            <a:schemeClr val="accent2"/>
-          </a:solidFill>
-          <a:ln/>
-        </p:spPr>
-      </p:sp>
-      <p:sp>
-        <p:nvSpPr>
-          <p:cNvPr id="10" name="Text 8"/>
-          <p:cNvSpPr txBox="1"/>
-          <p:nvPr/>
-        </p:nvSpPr>
-        <p:spPr>
-          <a:xfrm>
-            <a:off x="4937760" y="1371600"/>
-            <a:ext cx="502920" cy="502920"/>
-          </a:xfrm>
-          <a:prstGeom prst="rect">
-            <a:avLst/>
-          </a:prstGeom>
-          <a:noFill/>
-          <a:ln/>
-        </p:spPr>
-        <p:txBody>
-          <a:bodyPr wrap="square" lIns="0" tIns="0" rIns="0" bIns="0" rtlCol="0" anchor="ctr"/>
-          <a:lstStyle/>
-          <a:p>
-            <a:pPr algn="ctr" indent="0" marL="0">
-              <a:buNone/>
-            </a:pPr>
-            <a:r>
-              <a:rPr lang="en-US" sz="2000" b="1" dirty="0">
-                <a:solidFill>
-                  <a:schemeClr val="bg1"/>
-                </a:solidFill>
-              </a:rPr>
-              <a:t>+</a:t>
-            </a:r>
-            <a:endParaRPr lang="en-US" sz="2000" dirty="0"/>
-          </a:p>
-        </p:txBody>
-      </p:sp>
-      <p:sp>
-        <p:nvSpPr>
-          <p:cNvPr id="11" name="Text 9"/>
-          <p:cNvSpPr txBox="1"/>
-          <p:nvPr/>
-        </p:nvSpPr>
-        <p:spPr>
-          <a:xfrm>
-            <a:off x="5577840" y="1417320"/>
-            <a:ext cx="2926080" cy="411480"/>
-          </a:xfrm>
-          <a:prstGeom prst="rect">
-            <a:avLst/>
-          </a:prstGeom>
-          <a:noFill/>
-          <a:ln/>
-        </p:spPr>
-        <p:txBody>
-          <a:bodyPr wrap="square" lIns="0" tIns="0" rIns="0" bIns="0" rtlCol="0" anchor="ctr"/>
-          <a:lstStyle/>
-          <a:p>
-            <a:pPr indent="0" marL="0">
-              <a:buNone/>
-            </a:pPr>
-            <a:r>
-              <a:rPr lang="en-US" sz="2000" b="1" dirty="0">
-                <a:solidFill>
-                  <a:schemeClr val="tx1"/>
-                </a:solidFill>
-                <a:latin typeface="Cambria" pitchFamily="34" charset="0"/>
-                <a:ea typeface="Cambria" pitchFamily="34" charset="-122"/>
-                <a:cs typeface="Cambria" pitchFamily="34" charset="-120"/>
-              </a:rPr>
-              <a:t>Adding a service</a:t>
-            </a:r>
-            <a:endParaRPr lang="en-US" sz="2000" dirty="0"/>
-          </a:p>
-        </p:txBody>
-      </p:sp>
-      <p:sp>
-        <p:nvSpPr>
-          <p:cNvPr id="12" name="Text 10"/>
-          <p:cNvSpPr txBox="1"/>
-          <p:nvPr/>
-        </p:nvSpPr>
-        <p:spPr>
-          <a:xfrm>
-            <a:off x="4937760" y="2057400"/>
-            <a:ext cx="3566160" cy="2377440"/>
-          </a:xfrm>
-          <a:prstGeom prst="rect">
-            <a:avLst/>
-          </a:prstGeom>
-          <a:noFill/>
-          <a:ln/>
-        </p:spPr>
-        <p:txBody>
-          <a:bodyPr wrap="square" rtlCol="0" anchor="t"/>
-          <a:lstStyle/>
-          <a:p>
-            <a:pPr marL="342900" indent="-342900">
-              <a:spcAft>
-                <a:spcPts val="800"/>
-              </a:spcAft>
-              <a:buSzPct val="100000"/>
-              <a:buChar char="•"/>
-            </a:pPr>
-            <a:r>
-              <a:rPr lang="en-US" sz="1400" dirty="0">
-                <a:solidFill>
-                  <a:schemeClr val="tx2"/>
-                </a:solidFill>
-              </a:rPr>
-              <a:t>Add its official MCP server to .mcp.json</a:t>
-            </a:r>
-            <a:endParaRPr lang="en-US" sz="1400" dirty="0"/>
-          </a:p>
-          <a:p>
-            <a:pPr marL="342900" indent="-342900">
-              <a:spcAft>
-                <a:spcPts val="800"/>
-              </a:spcAft>
-              <a:buSzPct val="100000"/>
-              <a:buChar char="•"/>
-            </a:pPr>
-            <a:r>
-              <a:rPr lang="en-US" sz="1400" dirty="0">
-                <a:solidFill>
-                  <a:schemeClr val="tx2"/>
-                </a:solidFill>
-              </a:rPr>
-              <a:t>Add a section to localStorageFormats.md</a:t>
-            </a:r>
-            <a:endParaRPr lang="en-US" sz="1400" dirty="0"/>
-          </a:p>
-          <a:p>
-            <a:pPr marL="342900" indent="-342900">
-              <a:spcAft>
-                <a:spcPts val="800"/>
-              </a:spcAft>
-              <a:buSzPct val="100000"/>
-              <a:buChar char="•"/>
-            </a:pPr>
-            <a:r>
-              <a:rPr lang="en-US" sz="1400" dirty="0">
-                <a:solidFill>
-                  <a:schemeClr val="tx2"/>
-                </a:solidFill>
-              </a:rPr>
-              <a:t>Add a download-&lt;service&gt; skill</a:t>
-            </a:r>
-            <a:endParaRPr lang="en-US" sz="1400" dirty="0"/>
-          </a:p>
-          <a:p>
-            <a:pPr marL="342900" indent="-342900">
-              <a:spcAft>
-                <a:spcPts val="800"/>
-              </a:spcAft>
-              <a:buSzPct val="100000"/>
-              <a:buChar char="•"/>
-            </a:pPr>
-            <a:r>
-              <a:rPr lang="en-US" sz="1400" dirty="0">
-                <a:solidFill>
-                  <a:schemeClr val="tx2"/>
-                </a:solidFill>
-              </a:rPr>
-              <a:t>Save with save_export.py; the dashboard picks it up</a:t>
-            </a:r>
-            <a:endParaRPr lang="en-US" sz="1400" dirty="0"/>
-          </a:p>
-        </p:txBody>
-      </p:sp>
-      <p:sp>
-        <p:nvSpPr>
-          <p:cNvPr id="25" name="Slide Number Placeholder 0"/>
+      <p:grpSpPr/>
+      <p:sp>
+        <p:nvSpPr>
+          <p:cNvPr id="2" name="Title 1"/>
           <p:cNvSpPr>
             <a:spLocks noGrp="1"/>
           </p:cNvSpPr>
           <p:nvPr>
-            <p:ph type="sldNum" sz="quarter" idx="4294967295"/>
+            <p:ph type="title" idx="100"/>
           </p:nvPr>
         </p:nvSpPr>
         <p:spPr>
           <a:xfrm>
-            <a:off x="8412480" y="4754880"/>
-            <a:ext cx="457200" cy="274320"/>
-          </a:xfrm>
-          <a:prstGeom prst="rect">
-            <a:avLst/>
-          </a:prstGeom>
-          <a:extLst>
-            <a:ext uri="{C572A759-6A51-4108-AA02-DFA0A04FC94B}">
-              <ma14:wrappingTextBoxFlag xmlns:ma14="http://schemas.microsoft.com/office/mac/drawingml/2011/main" val="0"/>
-            </a:ext>
-          </a:extLst>
-        </p:spPr>
-        <p:txBody>
-          <a:bodyPr/>
-          <a:lstStyle>
-            <a:lvl1pPr>
-              <a:defRPr sz="1000">
+            <a:off x="457200" y="274320"/>
+            <a:ext cx="8229600" cy="685800"/>
+          </a:xfrm>
+        </p:spPr>
+        <p:txBody>
+          <a:bodyPr wrap="square" lIns="0" tIns="0" rIns="0" bIns="0" rtlCol="0" anchor="ctr"/>
+          <a:lstStyle/>
+          <a:p>
+            <a:r>
+              <a:rPr sz="3000" b="1"/>
+              <a:t>Notion: original and in the dashboard</a:t>
+            </a:r>
+          </a:p>
+        </p:txBody>
+      </p:sp>
+      <p:sp>
+        <p:nvSpPr>
+          <p:cNvPr id="3" name="TextBox 2"/>
+          <p:cNvSpPr txBox="1"/>
+          <p:nvPr/>
+        </p:nvSpPr>
+        <p:spPr>
+          <a:xfrm>
+            <a:off x="457200" y="1097280"/>
+            <a:ext cx="4023360" cy="320040"/>
+          </a:xfrm>
+          <a:prstGeom prst="rect">
+            <a:avLst/>
+          </a:prstGeom>
+          <a:noFill/>
+        </p:spPr>
+        <p:txBody>
+          <a:bodyPr wrap="none" lIns="0" rIns="0">
+            <a:spAutoFit/>
+          </a:bodyPr>
+          <a:lstStyle/>
+          <a:p>
+            <a:r>
+              <a:rPr sz="1400" b="1">
+                <a:solidFill>
+                  <a:schemeClr val="accent1"/>
+                </a:solidFill>
+              </a:rPr>
+              <a:t>In Notion</a:t>
+            </a:r>
+          </a:p>
+        </p:txBody>
+      </p:sp>
+      <p:sp>
+        <p:nvSpPr>
+          <p:cNvPr id="4" name="TextBox 3"/>
+          <p:cNvSpPr txBox="1"/>
+          <p:nvPr/>
+        </p:nvSpPr>
+        <p:spPr>
+          <a:xfrm>
+            <a:off x="4663440" y="1097280"/>
+            <a:ext cx="4023360" cy="320040"/>
+          </a:xfrm>
+          <a:prstGeom prst="rect">
+            <a:avLst/>
+          </a:prstGeom>
+          <a:noFill/>
+        </p:spPr>
+        <p:txBody>
+          <a:bodyPr wrap="none" lIns="0" rIns="0">
+            <a:spAutoFit/>
+          </a:bodyPr>
+          <a:lstStyle/>
+          <a:p>
+            <a:r>
+              <a:rPr sz="1400" b="1">
+                <a:solidFill>
+                  <a:schemeClr val="accent1"/>
+                </a:solidFill>
+              </a:rPr>
+              <a:t>In the dashboard</a:t>
+            </a:r>
+          </a:p>
+        </p:txBody>
+      </p:sp>
+      <p:pic>
+        <p:nvPicPr>
+          <p:cNvPr id="5" name="Picture 4" descr="notion-original.jpg"/>
+          <p:cNvPicPr>
+            <a:picLocks noChangeAspect="1"/>
+          </p:cNvPicPr>
+          <p:nvPr/>
+        </p:nvPicPr>
+        <p:blipFill>
+          <a:blip r:embed="rId2"/>
+          <a:stretch>
+            <a:fillRect/>
+          </a:stretch>
+        </p:blipFill>
+        <p:spPr>
+          <a:xfrm>
+            <a:off x="457200" y="1463040"/>
+            <a:ext cx="4023360" cy="2539746"/>
+          </a:xfrm>
+          <a:prstGeom prst="rect">
+            <a:avLst/>
+          </a:prstGeom>
+        </p:spPr>
+      </p:pic>
+      <p:pic>
+        <p:nvPicPr>
+          <p:cNvPr id="6" name="Picture 5" descr="notion-dashboard.jpg"/>
+          <p:cNvPicPr>
+            <a:picLocks noChangeAspect="1"/>
+          </p:cNvPicPr>
+          <p:nvPr/>
+        </p:nvPicPr>
+        <p:blipFill>
+          <a:blip r:embed="rId3"/>
+          <a:stretch>
+            <a:fillRect/>
+          </a:stretch>
+        </p:blipFill>
+        <p:spPr>
+          <a:xfrm>
+            <a:off x="4663440" y="1463040"/>
+            <a:ext cx="4023360" cy="2539746"/>
+          </a:xfrm>
+          <a:prstGeom prst="rect">
+            <a:avLst/>
+          </a:prstGeom>
+        </p:spPr>
+      </p:pic>
+      <p:sp>
+        <p:nvSpPr>
+          <p:cNvPr id="7" name="TextBox 6"/>
+          <p:cNvSpPr txBox="1"/>
+          <p:nvPr/>
+        </p:nvSpPr>
+        <p:spPr>
+          <a:xfrm>
+            <a:off x="457200" y="4114800"/>
+            <a:ext cx="8229600" cy="365760"/>
+          </a:xfrm>
+          <a:prstGeom prst="rect">
+            <a:avLst/>
+          </a:prstGeom>
+          <a:noFill/>
+        </p:spPr>
+        <p:txBody>
+          <a:bodyPr wrap="none" lIns="0">
+            <a:spAutoFit/>
+          </a:bodyPr>
+          <a:lstStyle/>
+          <a:p>
+            <a:r>
+              <a:rPr sz="1200">
                 <a:solidFill>
                   <a:schemeClr val="accent3"/>
                 </a:solidFill>
-              </a:defRPr>
-            </a:lvl1pPr>
-          </a:lstStyle>
-          <a:p>
-            <a:pPr algn="l"/>
-            <a:fld id="{F7021451-1387-4CA6-816F-3879F97B5CBC}" type="slidenum">
-              <a:rPr b="0" lang="en-US"/>
-              <a:t>7</a:t>
-            </a:fld>
-            <a:endParaRPr lang="en-US"/>
+              </a:rPr>
+              <a:t>Notion page “Client Call with Sarah Kim – Oct 16”</a:t>
+            </a:r>
           </a:p>
         </p:txBody>
       </p:sp>
@@ -5540,109 +6060,378 @@
 </file>
 
 <file path=ppt/slides/slide8.xml><?xml version="1.0" encoding="utf-8"?>
-<p:sld xmlns:a="http://schemas.openxmlformats.org/drawingml/2006/main" xmlns:r="http://schemas.openxmlformats.org/officeDocument/2006/relationships" xmlns:p="http://schemas.openxmlformats.org/presentationml/2006/main">
-  <p:cSld name="Slide 8">
+<p:sld xmlns:a="http://schemas.openxmlformats.org/drawingml/2006/main" xmlns:p="http://schemas.openxmlformats.org/presentationml/2006/main" xmlns:r="http://schemas.openxmlformats.org/officeDocument/2006/relationships">
+  <p:cSld>
     <p:spTree>
       <p:nvGrpSpPr>
         <p:cNvPr id="1" name=""/>
         <p:cNvGrpSpPr/>
         <p:nvPr/>
       </p:nvGrpSpPr>
-      <p:grpSpPr>
-        <a:xfrm>
-          <a:off x="0" y="0"/>
-          <a:ext cx="0" cy="0"/>
-          <a:chOff x="0" y="0"/>
-          <a:chExt cx="0" cy="0"/>
-        </a:xfrm>
-      </p:grpSpPr>
-      <p:sp>
-        <p:nvSpPr>
-          <p:cNvPr id="2" name="Text 0"/>
-          <p:cNvSpPr/>
+      <p:grpSpPr/>
+      <p:sp>
+        <p:nvSpPr>
+          <p:cNvPr id="2" name="Title 1"/>
+          <p:cNvSpPr>
+            <a:spLocks noGrp="1"/>
+          </p:cNvSpPr>
           <p:nvPr>
-            <p:ph idx="100" type="title" hasCustomPrompt="1"/>
+            <p:ph type="title" idx="100"/>
           </p:nvPr>
         </p:nvSpPr>
         <p:spPr>
           <a:xfrm>
-            <a:off x="548640" y="1371600"/>
-            <a:ext cx="8046720" cy="1188720"/>
-          </a:xfrm>
-          <a:prstGeom prst="rect">
-            <a:avLst/>
-          </a:prstGeom>
-          <a:noFill/>
-          <a:ln/>
-        </p:spPr>
-        <p:txBody>
-          <a:bodyPr wrap="square" rtlCol="0" anchor="b"/>
-          <a:lstStyle/>
-          <a:p>
-            <a:pPr indent="0" marL="0">
-              <a:buNone/>
-            </a:pPr>
-            <a:r>
-              <a:rPr lang="en-US" sz="4000" b="1" dirty="0">
-                <a:solidFill>
-                  <a:schemeClr val="bg1"/>
-                </a:solidFill>
-              </a:rPr>
-              <a:t>Thank you</a:t>
-            </a:r>
-            <a:endParaRPr lang="en-US" sz="4000" dirty="0"/>
-          </a:p>
-        </p:txBody>
-      </p:sp>
-      <p:sp>
-        <p:nvSpPr>
-          <p:cNvPr id="3" name="Text 0"/>
-          <p:cNvSpPr/>
+            <a:off x="457200" y="274320"/>
+            <a:ext cx="8229600" cy="685800"/>
+          </a:xfrm>
+        </p:spPr>
+        <p:txBody>
+          <a:bodyPr wrap="square" lIns="0" tIns="0" rIns="0" bIns="0" rtlCol="0" anchor="ctr"/>
+          <a:lstStyle/>
+          <a:p>
+            <a:r>
+              <a:rPr sz="3000" b="1"/>
+              <a:t>GitHub: original and in the dashboard</a:t>
+            </a:r>
+          </a:p>
+        </p:txBody>
+      </p:sp>
+      <p:sp>
+        <p:nvSpPr>
+          <p:cNvPr id="3" name="TextBox 2"/>
+          <p:cNvSpPr txBox="1"/>
+          <p:nvPr/>
+        </p:nvSpPr>
+        <p:spPr>
+          <a:xfrm>
+            <a:off x="457200" y="1097280"/>
+            <a:ext cx="4023360" cy="320040"/>
+          </a:xfrm>
+          <a:prstGeom prst="rect">
+            <a:avLst/>
+          </a:prstGeom>
+          <a:noFill/>
+        </p:spPr>
+        <p:txBody>
+          <a:bodyPr wrap="none" lIns="0" rIns="0">
+            <a:spAutoFit/>
+          </a:bodyPr>
+          <a:lstStyle/>
+          <a:p>
+            <a:r>
+              <a:rPr sz="1400" b="1">
+                <a:solidFill>
+                  <a:schemeClr val="accent1"/>
+                </a:solidFill>
+              </a:rPr>
+              <a:t>In GitHub</a:t>
+            </a:r>
+          </a:p>
+        </p:txBody>
+      </p:sp>
+      <p:sp>
+        <p:nvSpPr>
+          <p:cNvPr id="4" name="TextBox 3"/>
+          <p:cNvSpPr txBox="1"/>
+          <p:nvPr/>
+        </p:nvSpPr>
+        <p:spPr>
+          <a:xfrm>
+            <a:off x="4663440" y="1097280"/>
+            <a:ext cx="4023360" cy="320040"/>
+          </a:xfrm>
+          <a:prstGeom prst="rect">
+            <a:avLst/>
+          </a:prstGeom>
+          <a:noFill/>
+        </p:spPr>
+        <p:txBody>
+          <a:bodyPr wrap="none" lIns="0" rIns="0">
+            <a:spAutoFit/>
+          </a:bodyPr>
+          <a:lstStyle/>
+          <a:p>
+            <a:r>
+              <a:rPr sz="1400" b="1">
+                <a:solidFill>
+                  <a:schemeClr val="accent1"/>
+                </a:solidFill>
+              </a:rPr>
+              <a:t>In the dashboard</a:t>
+            </a:r>
+          </a:p>
+        </p:txBody>
+      </p:sp>
+      <p:pic>
+        <p:nvPicPr>
+          <p:cNvPr id="5" name="Picture 4" descr="github-original.jpg"/>
+          <p:cNvPicPr>
+            <a:picLocks noChangeAspect="1"/>
+          </p:cNvPicPr>
+          <p:nvPr/>
+        </p:nvPicPr>
+        <p:blipFill>
+          <a:blip r:embed="rId2"/>
+          <a:stretch>
+            <a:fillRect/>
+          </a:stretch>
+        </p:blipFill>
+        <p:spPr>
+          <a:xfrm>
+            <a:off x="457200" y="1463040"/>
+            <a:ext cx="4023360" cy="2539746"/>
+          </a:xfrm>
+          <a:prstGeom prst="rect">
+            <a:avLst/>
+          </a:prstGeom>
+        </p:spPr>
+      </p:pic>
+      <p:pic>
+        <p:nvPicPr>
+          <p:cNvPr id="6" name="Picture 5" descr="github-dashboard.jpg"/>
+          <p:cNvPicPr>
+            <a:picLocks noChangeAspect="1"/>
+          </p:cNvPicPr>
+          <p:nvPr/>
+        </p:nvPicPr>
+        <p:blipFill>
+          <a:blip r:embed="rId3"/>
+          <a:stretch>
+            <a:fillRect/>
+          </a:stretch>
+        </p:blipFill>
+        <p:spPr>
+          <a:xfrm>
+            <a:off x="4663440" y="1463040"/>
+            <a:ext cx="4023360" cy="2539746"/>
+          </a:xfrm>
+          <a:prstGeom prst="rect">
+            <a:avLst/>
+          </a:prstGeom>
+        </p:spPr>
+      </p:pic>
+      <p:sp>
+        <p:nvSpPr>
+          <p:cNvPr id="7" name="TextBox 6"/>
+          <p:cNvSpPr txBox="1"/>
+          <p:nvPr/>
+        </p:nvSpPr>
+        <p:spPr>
+          <a:xfrm>
+            <a:off x="457200" y="4114800"/>
+            <a:ext cx="8229600" cy="365760"/>
+          </a:xfrm>
+          <a:prstGeom prst="rect">
+            <a:avLst/>
+          </a:prstGeom>
+          <a:noFill/>
+        </p:spPr>
+        <p:txBody>
+          <a:bodyPr wrap="none" lIns="0">
+            <a:spAutoFit/>
+          </a:bodyPr>
+          <a:lstStyle/>
+          <a:p>
+            <a:r>
+              <a:rPr sz="1200">
+                <a:solidFill>
+                  <a:schemeClr val="accent3"/>
+                </a:solidFill>
+              </a:rPr>
+              <a:t>Issue #1 in nyohayon-jpg/apollo-data-importer</a:t>
+            </a:r>
+          </a:p>
+        </p:txBody>
+      </p:sp>
+    </p:spTree>
+  </p:cSld>
+  <p:clrMapOvr>
+    <a:masterClrMapping/>
+  </p:clrMapOvr>
+</p:sld>
+</file>
+
+<file path=ppt/slides/slide9.xml><?xml version="1.0" encoding="utf-8"?>
+<p:sld xmlns:a="http://schemas.openxmlformats.org/drawingml/2006/main" xmlns:p="http://schemas.openxmlformats.org/presentationml/2006/main" xmlns:r="http://schemas.openxmlformats.org/officeDocument/2006/relationships">
+  <p:cSld>
+    <p:spTree>
+      <p:nvGrpSpPr>
+        <p:cNvPr id="1" name=""/>
+        <p:cNvGrpSpPr/>
+        <p:nvPr/>
+      </p:nvGrpSpPr>
+      <p:grpSpPr/>
+      <p:sp>
+        <p:nvSpPr>
+          <p:cNvPr id="2" name="Title 1"/>
+          <p:cNvSpPr>
+            <a:spLocks noGrp="1"/>
+          </p:cNvSpPr>
           <p:nvPr>
-            <p:ph idx="101" type="body" hasCustomPrompt="1"/>
+            <p:ph type="title" idx="100"/>
           </p:nvPr>
         </p:nvSpPr>
         <p:spPr>
           <a:xfrm>
-            <a:off x="548640" y="2697480"/>
-            <a:ext cx="8046720" cy="1097280"/>
-          </a:xfrm>
-          <a:prstGeom prst="rect">
-            <a:avLst/>
-          </a:prstGeom>
-          <a:noFill/>
-          <a:ln/>
-        </p:spPr>
-        <p:txBody>
-          <a:bodyPr wrap="square" rtlCol="0" anchor="t"/>
-          <a:lstStyle/>
-          <a:p>
-            <a:pPr indent="0" marL="0">
-              <a:buNone/>
-            </a:pPr>
-            <a:r>
-              <a:rPr lang="en-US" sz="1800" dirty="0">
-                <a:solidFill>
-                  <a:schemeClr val="accent4"/>
-                </a:solidFill>
-              </a:rPr>
-              <a:t>Questions?</a:t>
-            </a:r>
-            <a:endParaRPr lang="en-US" sz="1800" dirty="0"/>
-          </a:p>
-          <a:p>
-            <a:pPr indent="0" marL="0">
-              <a:buNone/>
-            </a:pPr>
-            <a:r>
-              <a:rPr lang="en-US" sz="1800" dirty="0">
-                <a:solidFill>
-                  <a:schemeClr val="accent4"/>
-                </a:solidFill>
-              </a:rPr>
-              <a:t>github.com/nyohayon-jpg/hw-services-dashboard</a:t>
-            </a:r>
-            <a:endParaRPr lang="en-US" sz="1800" dirty="0"/>
+            <a:off x="457200" y="274320"/>
+            <a:ext cx="8229600" cy="685800"/>
+          </a:xfrm>
+        </p:spPr>
+        <p:txBody>
+          <a:bodyPr wrap="square" lIns="0" tIns="0" rIns="0" bIns="0" rtlCol="0" anchor="ctr"/>
+          <a:lstStyle/>
+          <a:p>
+            <a:r>
+              <a:rPr sz="3000" b="1"/>
+              <a:t>Linear: original and in the dashboard</a:t>
+            </a:r>
+          </a:p>
+        </p:txBody>
+      </p:sp>
+      <p:sp>
+        <p:nvSpPr>
+          <p:cNvPr id="3" name="TextBox 2"/>
+          <p:cNvSpPr txBox="1"/>
+          <p:nvPr/>
+        </p:nvSpPr>
+        <p:spPr>
+          <a:xfrm>
+            <a:off x="457200" y="1097280"/>
+            <a:ext cx="4023360" cy="320040"/>
+          </a:xfrm>
+          <a:prstGeom prst="rect">
+            <a:avLst/>
+          </a:prstGeom>
+          <a:noFill/>
+        </p:spPr>
+        <p:txBody>
+          <a:bodyPr wrap="none" lIns="0" rIns="0">
+            <a:spAutoFit/>
+          </a:bodyPr>
+          <a:lstStyle/>
+          <a:p>
+            <a:r>
+              <a:rPr sz="1400" b="1">
+                <a:solidFill>
+                  <a:schemeClr val="accent1"/>
+                </a:solidFill>
+              </a:rPr>
+              <a:t>In Linear</a:t>
+            </a:r>
+          </a:p>
+        </p:txBody>
+      </p:sp>
+      <p:sp>
+        <p:nvSpPr>
+          <p:cNvPr id="4" name="TextBox 3"/>
+          <p:cNvSpPr txBox="1"/>
+          <p:nvPr/>
+        </p:nvSpPr>
+        <p:spPr>
+          <a:xfrm>
+            <a:off x="4663440" y="1097280"/>
+            <a:ext cx="4023360" cy="320040"/>
+          </a:xfrm>
+          <a:prstGeom prst="rect">
+            <a:avLst/>
+          </a:prstGeom>
+          <a:noFill/>
+        </p:spPr>
+        <p:txBody>
+          <a:bodyPr wrap="none" lIns="0" rIns="0">
+            <a:spAutoFit/>
+          </a:bodyPr>
+          <a:lstStyle/>
+          <a:p>
+            <a:r>
+              <a:rPr sz="1400" b="1">
+                <a:solidFill>
+                  <a:schemeClr val="accent1"/>
+                </a:solidFill>
+              </a:rPr>
+              <a:t>In the dashboard</a:t>
+            </a:r>
+          </a:p>
+        </p:txBody>
+      </p:sp>
+      <p:pic>
+        <p:nvPicPr>
+          <p:cNvPr id="5" name="Picture 4" descr="linear-original.jpg"/>
+          <p:cNvPicPr>
+            <a:picLocks noChangeAspect="1"/>
+          </p:cNvPicPr>
+          <p:nvPr/>
+        </p:nvPicPr>
+        <p:blipFill>
+          <a:blip r:embed="rId2"/>
+          <a:stretch>
+            <a:fillRect/>
+          </a:stretch>
+        </p:blipFill>
+        <p:spPr>
+          <a:xfrm>
+            <a:off x="457200" y="1463040"/>
+            <a:ext cx="4023360" cy="2539746"/>
+          </a:xfrm>
+          <a:prstGeom prst="rect">
+            <a:avLst/>
+          </a:prstGeom>
+        </p:spPr>
+      </p:pic>
+      <p:pic>
+        <p:nvPicPr>
+          <p:cNvPr id="6" name="Picture 5" descr="linear-dashboard.jpg"/>
+          <p:cNvPicPr>
+            <a:picLocks noChangeAspect="1"/>
+          </p:cNvPicPr>
+          <p:nvPr/>
+        </p:nvPicPr>
+        <p:blipFill>
+          <a:blip r:embed="rId3"/>
+          <a:stretch>
+            <a:fillRect/>
+          </a:stretch>
+        </p:blipFill>
+        <p:spPr>
+          <a:xfrm>
+            <a:off x="4663440" y="1463040"/>
+            <a:ext cx="4023360" cy="2539746"/>
+          </a:xfrm>
+          <a:prstGeom prst="rect">
+            <a:avLst/>
+          </a:prstGeom>
+        </p:spPr>
+      </p:pic>
+      <p:sp>
+        <p:nvSpPr>
+          <p:cNvPr id="7" name="TextBox 6"/>
+          <p:cNvSpPr txBox="1"/>
+          <p:nvPr/>
+        </p:nvSpPr>
+        <p:spPr>
+          <a:xfrm>
+            <a:off x="457200" y="4114800"/>
+            <a:ext cx="8229600" cy="365760"/>
+          </a:xfrm>
+          <a:prstGeom prst="rect">
+            <a:avLst/>
+          </a:prstGeom>
+          <a:noFill/>
+        </p:spPr>
+        <p:txBody>
+          <a:bodyPr wrap="none" lIns="0">
+            <a:spAutoFit/>
+          </a:bodyPr>
+          <a:lstStyle/>
+          <a:p>
+            <a:r>
+              <a:rPr sz="1200">
+                <a:solidFill>
+                  <a:schemeClr val="accent3"/>
+                </a:solidFill>
+              </a:rPr>
+              <a:t>Issue BLU-7 in the Project Apollo project</a:t>
+            </a:r>
           </a:p>
         </p:txBody>
       </p:sp>

</xml_diff>